<commit_message>
Updated PDFs from New PPTXs
</commit_message>
<xml_diff>
--- a/static/uploads/modules/Parenting.pptx
+++ b/static/uploads/modules/Parenting.pptx
@@ -5,7 +5,7 @@
     <p:sldMasterId id="2147483648" r:id="rId1"/>
   </p:sldMasterIdLst>
   <p:notesMasterIdLst>
-    <p:notesMasterId r:id="rId25"/>
+    <p:notesMasterId r:id="rId24"/>
   </p:notesMasterIdLst>
   <p:sldIdLst>
     <p:sldId id="256" r:id="rId2"/>
@@ -13,24 +13,24 @@
     <p:sldId id="258" r:id="rId4"/>
     <p:sldId id="259" r:id="rId5"/>
     <p:sldId id="260" r:id="rId6"/>
+    <p:sldId id="300" r:id="rId40"/>
     <p:sldId id="261" r:id="rId7"/>
     <p:sldId id="262" r:id="rId8"/>
     <p:sldId id="263" r:id="rId9"/>
-    <p:sldId id="264" r:id="rId10"/>
-    <p:sldId id="265" r:id="rId11"/>
-    <p:sldId id="266" r:id="rId12"/>
-    <p:sldId id="267" r:id="rId13"/>
-    <p:sldId id="268" r:id="rId14"/>
-    <p:sldId id="269" r:id="rId15"/>
-    <p:sldId id="270" r:id="rId16"/>
-    <p:sldId id="271" r:id="rId17"/>
-    <p:sldId id="272" r:id="rId18"/>
-    <p:sldId id="273" r:id="rId19"/>
-    <p:sldId id="274" r:id="rId20"/>
-    <p:sldId id="275" r:id="rId21"/>
-    <p:sldId id="276" r:id="rId22"/>
-    <p:sldId id="277" r:id="rId23"/>
-    <p:sldId id="278" r:id="rId24"/>
+    <p:sldId id="265" r:id="rId10"/>
+    <p:sldId id="266" r:id="rId11"/>
+    <p:sldId id="267" r:id="rId12"/>
+    <p:sldId id="268" r:id="rId13"/>
+    <p:sldId id="269" r:id="rId14"/>
+    <p:sldId id="270" r:id="rId15"/>
+    <p:sldId id="271" r:id="rId16"/>
+    <p:sldId id="272" r:id="rId17"/>
+    <p:sldId id="273" r:id="rId18"/>
+    <p:sldId id="274" r:id="rId19"/>
+    <p:sldId id="275" r:id="rId20"/>
+    <p:sldId id="276" r:id="rId21"/>
+    <p:sldId id="277" r:id="rId22"/>
+    <p:sldId id="278" r:id="rId23"/>
   </p:sldIdLst>
   <p:sldSz cx="9144000" cy="5143500" type="screen16x9"/>
   <p:notesSz cx="5143500" cy="9144000"/>
@@ -143,7 +143,6 @@
             <p14:sldId id="261"/>
             <p14:sldId id="262"/>
             <p14:sldId id="263"/>
-            <p14:sldId id="264"/>
           </p14:sldIdLst>
         </p14:section>
         <p14:section name="Quiz" id="{0CBD4C80-D572-FAEE-2B5C-9B88E890B7EB}">
@@ -436,7 +435,10 @@
           <a:bodyPr/>
           <a:lstStyle/>
           <a:p>
-            <a:endParaRPr lang="en-US" dirty="0"/>
+            <a:r>
+              <a:rPr lang="en-US" dirty="0"/>
+              <a:t>Correct answer: B. Early-discharge babies need a definite appointment and an exam within 48 hours of discharge.</a:t>
+            </a:r>
           </a:p>
         </p:txBody>
       </p:sp>
@@ -520,10 +522,7 @@
           <a:bodyPr/>
           <a:lstStyle/>
           <a:p>
-            <a:r>
-              <a:rPr lang="en-US" dirty="0"/>
-              <a:t>Correct answer: B. Early-discharge babies need a definite appointment and an exam within 48 hours of discharge.</a:t>
-            </a:r>
+            <a:endParaRPr lang="en-US" dirty="0"/>
           </a:p>
         </p:txBody>
       </p:sp>
@@ -691,7 +690,10 @@
           <a:bodyPr/>
           <a:lstStyle/>
           <a:p>
-            <a:endParaRPr lang="en-US" dirty="0"/>
+            <a:r>
+              <a:rPr lang="en-US" dirty="0"/>
+              <a:t>Correct answer: C. Refrigerator (4°C): up to 8 days. Room temperature below 25°C: 4 hours. Freezer of a 2-door fridge: 3 months.</a:t>
+            </a:r>
           </a:p>
         </p:txBody>
       </p:sp>
@@ -775,10 +777,7 @@
           <a:bodyPr/>
           <a:lstStyle/>
           <a:p>
-            <a:r>
-              <a:rPr lang="en-US" dirty="0"/>
-              <a:t>Correct answer: C. Refrigerator (4°C): up to 8 days. Room temperature below 25°C: 4 hours. Freezer of a 2-door fridge: 3 months.</a:t>
-            </a:r>
+            <a:endParaRPr lang="en-US" dirty="0"/>
           </a:p>
         </p:txBody>
       </p:sp>
@@ -946,7 +945,10 @@
           <a:bodyPr/>
           <a:lstStyle/>
           <a:p>
-            <a:endParaRPr lang="en-US" dirty="0"/>
+            <a:r>
+              <a:rPr lang="en-US" dirty="0"/>
+              <a:t>Correct answer: A. Baby’s head, back and hips are aligned and facing the breast: face to face, chest to chest, tummy to tummy.</a:t>
+            </a:r>
           </a:p>
         </p:txBody>
       </p:sp>
@@ -1030,10 +1032,7 @@
           <a:bodyPr/>
           <a:lstStyle/>
           <a:p>
-            <a:r>
-              <a:rPr lang="en-US" dirty="0"/>
-              <a:t>Correct answer: A. Baby’s head, back and hips are aligned and facing the breast: face to face, chest to chest, tummy to tummy.</a:t>
-            </a:r>
+            <a:endParaRPr lang="en-US" dirty="0"/>
           </a:p>
         </p:txBody>
       </p:sp>
@@ -1201,7 +1200,10 @@
           <a:bodyPr/>
           <a:lstStyle/>
           <a:p>
-            <a:endParaRPr lang="en-US" dirty="0"/>
+            <a:r>
+              <a:rPr lang="en-US" dirty="0"/>
+              <a:t>Correct answer: B. Believe the child, thank them, let them talk without leading questions, and seek professional help.</a:t>
+            </a:r>
           </a:p>
         </p:txBody>
       </p:sp>
@@ -1372,10 +1374,7 @@
           <a:bodyPr/>
           <a:lstStyle/>
           <a:p>
-            <a:r>
-              <a:rPr lang="en-US" dirty="0"/>
-              <a:t>Correct answer: B. Believe the child, thank them, let them talk without leading questions, and seek professional help.</a:t>
-            </a:r>
+            <a:endParaRPr lang="en-US" dirty="0"/>
           </a:p>
         </p:txBody>
       </p:sp>
@@ -1543,7 +1542,10 @@
           <a:bodyPr/>
           <a:lstStyle/>
           <a:p>
-            <a:endParaRPr lang="en-US" dirty="0"/>
+            <a:r>
+              <a:rPr lang="en-US" dirty="0"/>
+              <a:t>Wrap-up. Source: REdbook notes (Parenting section).</a:t>
+            </a:r>
           </a:p>
         </p:txBody>
       </p:sp>
@@ -1565,93 +1567,6 @@
             <a:fld id="{F7021451-1387-4CA6-816F-3879F97B5CBC}" type="slidenum">
               <a:rPr lang="en-US"/>
               <a:t>22</a:t>
-            </a:fld>
-            <a:endParaRPr lang="en-US"/>
-          </a:p>
-        </p:txBody>
-      </p:sp>
-    </p:spTree>
-    <p:extLst>
-      <p:ext uri="{BB962C8B-B14F-4D97-AF65-F5344CB8AC3E}">
-        <p14:creationId xmlns:p14="http://schemas.microsoft.com/office/powerpoint/2010/main" val="1024086991"/>
-      </p:ext>
-    </p:extLst>
-  </p:cSld>
-  <p:clrMapOvr>
-    <a:masterClrMapping/>
-  </p:clrMapOvr>
-</p:notes>
-</file>
-
-<file path=ppt/notesSlides/notesSlide23.xml><?xml version="1.0" encoding="utf-8"?>
-<p:notes xmlns:a="http://schemas.openxmlformats.org/drawingml/2006/main" xmlns:r="http://schemas.openxmlformats.org/officeDocument/2006/relationships" xmlns:p="http://schemas.openxmlformats.org/presentationml/2006/main">
-  <p:cSld>
-    <p:spTree>
-      <p:nvGrpSpPr>
-        <p:cNvPr id="1" name=""/>
-        <p:cNvGrpSpPr/>
-        <p:nvPr/>
-      </p:nvGrpSpPr>
-      <p:grpSpPr>
-        <a:xfrm>
-          <a:off x="0" y="0"/>
-          <a:ext cx="0" cy="0"/>
-          <a:chOff x="0" y="0"/>
-          <a:chExt cx="0" cy="0"/>
-        </a:xfrm>
-      </p:grpSpPr>
-      <p:sp>
-        <p:nvSpPr>
-          <p:cNvPr id="2" name="Slide Image Placeholder 1"/>
-          <p:cNvSpPr>
-            <a:spLocks noGrp="1" noRot="1" noChangeAspect="1"/>
-          </p:cNvSpPr>
-          <p:nvPr>
-            <p:ph type="sldImg"/>
-          </p:nvPr>
-        </p:nvSpPr>
-        <p:spPr/>
-      </p:sp>
-      <p:sp>
-        <p:nvSpPr>
-          <p:cNvPr id="3" name="Notes Placeholder 2"/>
-          <p:cNvSpPr>
-            <a:spLocks noGrp="1"/>
-          </p:cNvSpPr>
-          <p:nvPr>
-            <p:ph type="body" idx="1"/>
-          </p:nvPr>
-        </p:nvSpPr>
-        <p:spPr/>
-        <p:txBody>
-          <a:bodyPr/>
-          <a:lstStyle/>
-          <a:p>
-            <a:r>
-              <a:rPr lang="en-US" dirty="0"/>
-              <a:t>Wrap-up. Source: REdbook notes (Parenting section).</a:t>
-            </a:r>
-          </a:p>
-        </p:txBody>
-      </p:sp>
-      <p:sp>
-        <p:nvSpPr>
-          <p:cNvPr id="4" name="Slide Number Placeholder 3"/>
-          <p:cNvSpPr>
-            <a:spLocks noGrp="1"/>
-          </p:cNvSpPr>
-          <p:nvPr>
-            <p:ph type="sldNum" sz="quarter" idx="10"/>
-          </p:nvPr>
-        </p:nvSpPr>
-        <p:spPr/>
-        <p:txBody>
-          <a:bodyPr/>
-          <a:lstStyle/>
-          <a:p>
-            <a:fld id="{F7021451-1387-4CA6-816F-3879F97B5CBC}" type="slidenum">
-              <a:rPr lang="en-US"/>
-              <a:t>23</a:t>
             </a:fld>
             <a:endParaRPr lang="en-US"/>
           </a:p>
@@ -2227,10 +2142,7 @@
           <a:bodyPr/>
           <a:lstStyle/>
           <a:p>
-            <a:r>
-              <a:rPr lang="en-US" dirty="0"/>
-              <a:t>HEEADSSS: Home, Education/employment, Eating, Activities, Drugs, Sexuality, Suicidality/depression, Safety. An additional S for strength/spirituality is recommended. Counseling also covers self breast examination for females.</a:t>
-            </a:r>
+            <a:endParaRPr lang="en-US" dirty="0"/>
           </a:p>
         </p:txBody>
       </p:sp>
@@ -2837,7 +2749,7 @@
                 <a:ea typeface="+mj-lt" pitchFamily="34" charset="-122"/>
                 <a:cs typeface="+mj-lt" pitchFamily="34" charset="-120"/>
               </a:rPr>
-              <a:t>Raising healthy children, from newborn to teen</a:t>
+              <a:t>Raising healthy children, from newborn</a:t>
             </a:r>
             <a:endParaRPr lang="en-US" sz="3800" dirty="0"/>
           </a:p>
@@ -2972,250 +2884,6 @@
 </file>
 
 <file path=ppt/slides/slide10.xml><?xml version="1.0" encoding="utf-8"?>
-<p:sld xmlns:a="http://schemas.openxmlformats.org/drawingml/2006/main" xmlns:r="http://schemas.openxmlformats.org/officeDocument/2006/relationships" xmlns:p="http://schemas.openxmlformats.org/presentationml/2006/main">
-  <p:cSld name="Slide 10">
-    <p:spTree>
-      <p:nvGrpSpPr>
-        <p:cNvPr id="1" name=""/>
-        <p:cNvGrpSpPr/>
-        <p:nvPr/>
-      </p:nvGrpSpPr>
-      <p:grpSpPr>
-        <a:xfrm>
-          <a:off x="0" y="0"/>
-          <a:ext cx="0" cy="0"/>
-          <a:chOff x="0" y="0"/>
-          <a:chExt cx="0" cy="0"/>
-        </a:xfrm>
-      </p:grpSpPr>
-      <p:pic>
-        <p:nvPicPr>
-          <p:cNvPr id="2" name="High five photo" descr="A father and his toddler high-five at sunset on the beach"/>
-          <p:cNvPicPr>
-            <a:picLocks noChangeAspect="1"/>
-          </p:cNvPicPr>
-          <p:nvPr/>
-        </p:nvPicPr>
-        <p:blipFill>
-          <a:blip r:embed="rId3"/>
-          <a:stretch>
-            <a:fillRect/>
-          </a:stretch>
-        </p:blipFill>
-        <p:spPr>
-          <a:xfrm>
-            <a:off x="4754880" y="0"/>
-            <a:ext cx="4389120" cy="5143500"/>
-          </a:xfrm>
-          <a:prstGeom prst="rect">
-            <a:avLst/>
-          </a:prstGeom>
-        </p:spPr>
-      </p:pic>
-      <p:sp>
-        <p:nvSpPr>
-          <p:cNvPr id="3" name="Eyebrow"/>
-          <p:cNvSpPr txBox="1"/>
-          <p:nvPr/>
-        </p:nvSpPr>
-        <p:spPr>
-          <a:xfrm>
-            <a:off x="548640" y="1097280"/>
-            <a:ext cx="3931920" cy="320040"/>
-          </a:xfrm>
-          <a:prstGeom prst="rect">
-            <a:avLst/>
-          </a:prstGeom>
-          <a:noFill/>
-          <a:ln/>
-        </p:spPr>
-        <p:txBody>
-          <a:bodyPr wrap="square" lIns="0" tIns="0" rIns="0" bIns="0" rtlCol="0" anchor="ctr"/>
-          <a:lstStyle/>
-          <a:p>
-            <a:pPr marL="0" indent="0">
-              <a:buNone/>
-            </a:pPr>
-            <a:r>
-              <a:rPr lang="en-US" sz="1400" b="1" kern="0" spc="400" dirty="0">
-                <a:solidFill>
-                  <a:schemeClr val="accent3"/>
-                </a:solidFill>
-              </a:rPr>
-              <a:t>QUICK QUIZ</a:t>
-            </a:r>
-            <a:endParaRPr lang="en-US" sz="1400" dirty="0"/>
-          </a:p>
-        </p:txBody>
-      </p:sp>
-      <p:sp>
-        <p:nvSpPr>
-          <p:cNvPr id="4" name="Quiz title"/>
-          <p:cNvSpPr txBox="1"/>
-          <p:nvPr/>
-        </p:nvSpPr>
-        <p:spPr>
-          <a:xfrm>
-            <a:off x="548640" y="1508760"/>
-            <a:ext cx="3931920" cy="1280160"/>
-          </a:xfrm>
-          <a:prstGeom prst="rect">
-            <a:avLst/>
-          </a:prstGeom>
-          <a:noFill/>
-          <a:ln/>
-        </p:spPr>
-        <p:txBody>
-          <a:bodyPr wrap="square" lIns="0" tIns="0" rIns="0" bIns="0" rtlCol="0" anchor="t"/>
-          <a:lstStyle/>
-          <a:p>
-            <a:pPr marL="0" indent="0">
-              <a:buNone/>
-            </a:pPr>
-            <a:r>
-              <a:rPr lang="en-US" sz="3600" b="1" dirty="0">
-                <a:solidFill>
-                  <a:schemeClr val="bg1"/>
-                </a:solidFill>
-                <a:latin typeface="+mj-lt" pitchFamily="34" charset="0"/>
-                <a:ea typeface="+mj-lt" pitchFamily="34" charset="-122"/>
-                <a:cs typeface="+mj-lt" pitchFamily="34" charset="-120"/>
-              </a:rPr>
-              <a:t>Test what you learned</a:t>
-            </a:r>
-            <a:endParaRPr lang="en-US" sz="3600" dirty="0"/>
-          </a:p>
-        </p:txBody>
-      </p:sp>
-      <p:sp>
-        <p:nvSpPr>
-          <p:cNvPr id="5" name="Quiz instructions"/>
-          <p:cNvSpPr txBox="1"/>
-          <p:nvPr/>
-        </p:nvSpPr>
-        <p:spPr>
-          <a:xfrm>
-            <a:off x="548640" y="2926080"/>
-            <a:ext cx="3840480" cy="822960"/>
-          </a:xfrm>
-          <a:prstGeom prst="rect">
-            <a:avLst/>
-          </a:prstGeom>
-          <a:noFill/>
-          <a:ln/>
-        </p:spPr>
-        <p:txBody>
-          <a:bodyPr wrap="square" lIns="0" tIns="0" rIns="0" bIns="0" rtlCol="0" anchor="t"/>
-          <a:lstStyle/>
-          <a:p>
-            <a:pPr marL="0" indent="0">
-              <a:buNone/>
-            </a:pPr>
-            <a:r>
-              <a:rPr lang="en-US" sz="1600" dirty="0">
-                <a:solidFill>
-                  <a:schemeClr val="bg1"/>
-                </a:solidFill>
-              </a:rPr>
-              <a:t>4 questions. Tap an answer to see if you got it right. Wrong answer? You can try again.</a:t>
-            </a:r>
-            <a:endParaRPr lang="en-US" sz="1600" dirty="0"/>
-          </a:p>
-        </p:txBody>
-      </p:sp>
-      <p:sp>
-        <p:nvSpPr>
-          <p:cNvPr id="6" name="Start quiz">
-            <a:hlinkClick r:id="rId4" action="ppaction://hlinksldjump" tooltip="Go to question 1"/>
-          </p:cNvPr>
-          <p:cNvSpPr/>
-          <p:nvPr/>
-        </p:nvSpPr>
-        <p:spPr>
-          <a:xfrm>
-            <a:off x="548640" y="3977640"/>
-            <a:ext cx="1645920" cy="420624"/>
-          </a:xfrm>
-          <a:prstGeom prst="roundRect">
-            <a:avLst>
-              <a:gd name="adj" fmla="val 50000"/>
-            </a:avLst>
-          </a:prstGeom>
-          <a:solidFill>
-            <a:schemeClr val="accent3"/>
-          </a:solidFill>
-          <a:ln/>
-        </p:spPr>
-        <p:txBody>
-          <a:bodyPr wrap="square" lIns="0" tIns="0" rIns="0" bIns="0" rtlCol="0" anchor="ctr"/>
-          <a:lstStyle/>
-          <a:p>
-            <a:pPr marL="0" indent="0" algn="ctr">
-              <a:buNone/>
-            </a:pPr>
-            <a:r>
-              <a:rPr lang="en-US" sz="1400" b="1" dirty="0">
-                <a:solidFill>
-                  <a:schemeClr val="tx1"/>
-                </a:solidFill>
-              </a:rPr>
-              <a:t>Start quiz</a:t>
-            </a:r>
-            <a:endParaRPr lang="en-US" sz="1400" dirty="0"/>
-          </a:p>
-        </p:txBody>
-      </p:sp>
-      <p:sp>
-        <p:nvSpPr>
-          <p:cNvPr id="7" name="Menu button">
-            <a:hlinkClick r:id="rId5" action="ppaction://hlinksldjump" tooltip="Back to the topic menu"/>
-          </p:cNvPr>
-          <p:cNvSpPr/>
-          <p:nvPr/>
-        </p:nvSpPr>
-        <p:spPr>
-          <a:xfrm>
-            <a:off x="2377440" y="3977640"/>
-            <a:ext cx="1280160" cy="420624"/>
-          </a:xfrm>
-          <a:prstGeom prst="roundRect">
-            <a:avLst>
-              <a:gd name="adj" fmla="val 50000"/>
-            </a:avLst>
-          </a:prstGeom>
-          <a:solidFill>
-            <a:schemeClr val="tx2"/>
-          </a:solidFill>
-          <a:ln/>
-        </p:spPr>
-        <p:txBody>
-          <a:bodyPr wrap="square" lIns="0" tIns="0" rIns="0" bIns="0" rtlCol="0" anchor="ctr"/>
-          <a:lstStyle/>
-          <a:p>
-            <a:pPr marL="0" indent="0" algn="ctr">
-              <a:buNone/>
-            </a:pPr>
-            <a:r>
-              <a:rPr lang="en-US" sz="1400" b="1" dirty="0">
-                <a:solidFill>
-                  <a:schemeClr val="bg1"/>
-                </a:solidFill>
-              </a:rPr>
-              <a:t>Menu</a:t>
-            </a:r>
-            <a:endParaRPr lang="en-US" sz="1400" dirty="0"/>
-          </a:p>
-        </p:txBody>
-      </p:sp>
-    </p:spTree>
-  </p:cSld>
-  <p:clrMapOvr>
-    <a:masterClrMapping/>
-  </p:clrMapOvr>
-</p:sld>
-</file>
-
-<file path=ppt/slides/slide11.xml><?xml version="1.0" encoding="utf-8"?>
 <p:sld xmlns:a="http://schemas.openxmlformats.org/drawingml/2006/main" xmlns:r="http://schemas.openxmlformats.org/officeDocument/2006/relationships" xmlns:p="http://schemas.openxmlformats.org/presentationml/2006/main">
   <p:cSld name="Slide 11">
     <p:spTree>
@@ -3568,7 +3236,7 @@
 </p:sld>
 </file>
 
-<file path=ppt/slides/slide12.xml><?xml version="1.0" encoding="utf-8"?>
+<file path=ppt/slides/slide11.xml><?xml version="1.0" encoding="utf-8"?>
 <p:sld xmlns:a="http://schemas.openxmlformats.org/drawingml/2006/main" xmlns:r="http://schemas.openxmlformats.org/officeDocument/2006/relationships" xmlns:p="http://schemas.openxmlformats.org/presentationml/2006/main">
   <p:cSld name="Slide 12">
     <p:spTree>
@@ -3841,7 +3509,7 @@
 </p:sld>
 </file>
 
-<file path=ppt/slides/slide13.xml><?xml version="1.0" encoding="utf-8"?>
+<file path=ppt/slides/slide12.xml><?xml version="1.0" encoding="utf-8"?>
 <p:sld xmlns:a="http://schemas.openxmlformats.org/drawingml/2006/main" xmlns:r="http://schemas.openxmlformats.org/officeDocument/2006/relationships" xmlns:p="http://schemas.openxmlformats.org/presentationml/2006/main">
   <p:cSld name="Slide 13">
     <p:spTree>
@@ -4114,7 +3782,7 @@
 </p:sld>
 </file>
 
-<file path=ppt/slides/slide14.xml><?xml version="1.0" encoding="utf-8"?>
+<file path=ppt/slides/slide13.xml><?xml version="1.0" encoding="utf-8"?>
 <p:sld xmlns:a="http://schemas.openxmlformats.org/drawingml/2006/main" xmlns:r="http://schemas.openxmlformats.org/officeDocument/2006/relationships" xmlns:p="http://schemas.openxmlformats.org/presentationml/2006/main">
   <p:cSld name="Slide 14">
     <p:spTree>
@@ -4467,7 +4135,7 @@
 </p:sld>
 </file>
 
-<file path=ppt/slides/slide15.xml><?xml version="1.0" encoding="utf-8"?>
+<file path=ppt/slides/slide14.xml><?xml version="1.0" encoding="utf-8"?>
 <p:sld xmlns:a="http://schemas.openxmlformats.org/drawingml/2006/main" xmlns:r="http://schemas.openxmlformats.org/officeDocument/2006/relationships" xmlns:p="http://schemas.openxmlformats.org/presentationml/2006/main">
   <p:cSld name="Slide 15">
     <p:spTree>
@@ -4740,7 +4408,7 @@
 </p:sld>
 </file>
 
-<file path=ppt/slides/slide16.xml><?xml version="1.0" encoding="utf-8"?>
+<file path=ppt/slides/slide15.xml><?xml version="1.0" encoding="utf-8"?>
 <p:sld xmlns:a="http://schemas.openxmlformats.org/drawingml/2006/main" xmlns:r="http://schemas.openxmlformats.org/officeDocument/2006/relationships" xmlns:p="http://schemas.openxmlformats.org/presentationml/2006/main">
   <p:cSld name="Slide 16">
     <p:spTree>
@@ -5013,7 +4681,7 @@
 </p:sld>
 </file>
 
-<file path=ppt/slides/slide17.xml><?xml version="1.0" encoding="utf-8"?>
+<file path=ppt/slides/slide16.xml><?xml version="1.0" encoding="utf-8"?>
 <p:sld xmlns:a="http://schemas.openxmlformats.org/drawingml/2006/main" xmlns:r="http://schemas.openxmlformats.org/officeDocument/2006/relationships" xmlns:p="http://schemas.openxmlformats.org/presentationml/2006/main">
   <p:cSld name="Slide 17">
     <p:spTree>
@@ -5366,7 +5034,7 @@
 </p:sld>
 </file>
 
-<file path=ppt/slides/slide18.xml><?xml version="1.0" encoding="utf-8"?>
+<file path=ppt/slides/slide17.xml><?xml version="1.0" encoding="utf-8"?>
 <p:sld xmlns:a="http://schemas.openxmlformats.org/drawingml/2006/main" xmlns:r="http://schemas.openxmlformats.org/officeDocument/2006/relationships" xmlns:p="http://schemas.openxmlformats.org/presentationml/2006/main">
   <p:cSld name="Slide 18">
     <p:spTree>
@@ -5639,7 +5307,7 @@
 </p:sld>
 </file>
 
-<file path=ppt/slides/slide19.xml><?xml version="1.0" encoding="utf-8"?>
+<file path=ppt/slides/slide18.xml><?xml version="1.0" encoding="utf-8"?>
 <p:sld xmlns:a="http://schemas.openxmlformats.org/drawingml/2006/main" xmlns:r="http://schemas.openxmlformats.org/officeDocument/2006/relationships" xmlns:p="http://schemas.openxmlformats.org/presentationml/2006/main">
   <p:cSld name="Slide 19">
     <p:spTree>
@@ -5901,6 +5569,359 @@
               <a:t>Menu</a:t>
             </a:r>
             <a:endParaRPr lang="en-US" sz="1400" dirty="0"/>
+          </a:p>
+        </p:txBody>
+      </p:sp>
+    </p:spTree>
+  </p:cSld>
+  <p:clrMapOvr>
+    <a:masterClrMapping/>
+  </p:clrMapOvr>
+</p:sld>
+</file>
+
+<file path=ppt/slides/slide19.xml><?xml version="1.0" encoding="utf-8"?>
+<p:sld xmlns:a="http://schemas.openxmlformats.org/drawingml/2006/main" xmlns:r="http://schemas.openxmlformats.org/officeDocument/2006/relationships" xmlns:p="http://schemas.openxmlformats.org/presentationml/2006/main">
+  <p:cSld name="Slide 20">
+    <p:spTree>
+      <p:nvGrpSpPr>
+        <p:cNvPr id="1" name=""/>
+        <p:cNvGrpSpPr/>
+        <p:nvPr/>
+      </p:nvGrpSpPr>
+      <p:grpSpPr>
+        <a:xfrm>
+          <a:off x="0" y="0"/>
+          <a:ext cx="0" cy="0"/>
+          <a:chOff x="0" y="0"/>
+          <a:chExt cx="0" cy="0"/>
+        </a:xfrm>
+      </p:grpSpPr>
+      <p:sp>
+        <p:nvSpPr>
+          <p:cNvPr id="2" name="Text 0"/>
+          <p:cNvSpPr>
+            <a:spLocks noGrp="1"/>
+          </p:cNvSpPr>
+          <p:nvPr>
+            <p:ph type="title" idx="100" hasCustomPrompt="1"/>
+          </p:nvPr>
+        </p:nvSpPr>
+        <p:spPr>
+          <a:xfrm>
+            <a:off x="457200" y="274320"/>
+            <a:ext cx="6949440" cy="640080"/>
+          </a:xfrm>
+          <a:prstGeom prst="rect">
+            <a:avLst/>
+          </a:prstGeom>
+          <a:noFill/>
+          <a:ln/>
+        </p:spPr>
+        <p:txBody>
+          <a:bodyPr wrap="square" lIns="0" tIns="0" rIns="0" bIns="0" rtlCol="0" anchor="ctr"/>
+          <a:lstStyle/>
+          <a:p>
+            <a:pPr marL="0" indent="0" algn="l">
+              <a:buNone/>
+            </a:pPr>
+            <a:r>
+              <a:rPr lang="en-US" sz="3000" b="1" dirty="0">
+                <a:solidFill>
+                  <a:schemeClr val="tx1"/>
+                </a:solidFill>
+              </a:rPr>
+              <a:t>Question 4 of 4</a:t>
+            </a:r>
+            <a:endParaRPr lang="en-US" sz="3000" dirty="0"/>
+          </a:p>
+        </p:txBody>
+      </p:sp>
+      <p:sp>
+        <p:nvSpPr>
+          <p:cNvPr id="3" name="Menu button">
+            <a:hlinkClick r:id="rId3" action="ppaction://hlinksldjump" tooltip="Back to the topic menu"/>
+          </p:cNvPr>
+          <p:cNvSpPr/>
+          <p:nvPr/>
+        </p:nvSpPr>
+        <p:spPr>
+          <a:xfrm>
+            <a:off x="7635240" y="365760"/>
+            <a:ext cx="1051560" cy="365760"/>
+          </a:xfrm>
+          <a:prstGeom prst="roundRect">
+            <a:avLst>
+              <a:gd name="adj" fmla="val 50000"/>
+            </a:avLst>
+          </a:prstGeom>
+          <a:solidFill>
+            <a:schemeClr val="tx1"/>
+          </a:solidFill>
+          <a:ln/>
+        </p:spPr>
+        <p:txBody>
+          <a:bodyPr wrap="square" lIns="0" tIns="0" rIns="0" bIns="0" rtlCol="0" anchor="ctr"/>
+          <a:lstStyle/>
+          <a:p>
+            <a:pPr marL="0" indent="0" algn="ctr">
+              <a:buNone/>
+            </a:pPr>
+            <a:r>
+              <a:rPr lang="en-US" sz="1400" b="1" dirty="0">
+                <a:solidFill>
+                  <a:schemeClr val="bg1"/>
+                </a:solidFill>
+              </a:rPr>
+              <a:t>Menu</a:t>
+            </a:r>
+            <a:endParaRPr lang="en-US" sz="1400" dirty="0"/>
+          </a:p>
+        </p:txBody>
+      </p:sp>
+      <p:sp>
+        <p:nvSpPr>
+          <p:cNvPr id="4" name="Topic label"/>
+          <p:cNvSpPr txBox="1"/>
+          <p:nvPr/>
+        </p:nvSpPr>
+        <p:spPr>
+          <a:xfrm>
+            <a:off x="457200" y="896112"/>
+            <a:ext cx="5486400" cy="274320"/>
+          </a:xfrm>
+          <a:prstGeom prst="rect">
+            <a:avLst/>
+          </a:prstGeom>
+          <a:noFill/>
+          <a:ln/>
+        </p:spPr>
+        <p:txBody>
+          <a:bodyPr wrap="square" lIns="0" tIns="0" rIns="0" bIns="0" rtlCol="0" anchor="ctr"/>
+          <a:lstStyle/>
+          <a:p>
+            <a:pPr marL="0" indent="0">
+              <a:buNone/>
+            </a:pPr>
+            <a:r>
+              <a:rPr lang="en-US" sz="1200" b="1" kern="0" spc="200" dirty="0">
+                <a:solidFill>
+                  <a:schemeClr val="accent1"/>
+                </a:solidFill>
+              </a:rPr>
+              <a:t>CHILD PROTECTION</a:t>
+            </a:r>
+            <a:endParaRPr lang="en-US" sz="1200" dirty="0"/>
+          </a:p>
+        </p:txBody>
+      </p:sp>
+      <p:sp>
+        <p:nvSpPr>
+          <p:cNvPr id="5" name="Question"/>
+          <p:cNvSpPr txBox="1"/>
+          <p:nvPr/>
+        </p:nvSpPr>
+        <p:spPr>
+          <a:xfrm>
+            <a:off x="457200" y="1188720"/>
+            <a:ext cx="8229600" cy="822960"/>
+          </a:xfrm>
+          <a:prstGeom prst="rect">
+            <a:avLst/>
+          </a:prstGeom>
+          <a:noFill/>
+          <a:ln/>
+        </p:spPr>
+        <p:txBody>
+          <a:bodyPr wrap="square" lIns="0" tIns="0" rIns="0" bIns="0" rtlCol="0" anchor="t"/>
+          <a:lstStyle/>
+          <a:p>
+            <a:pPr marL="0" indent="0">
+              <a:buNone/>
+            </a:pPr>
+            <a:r>
+              <a:rPr lang="en-US" sz="2200" b="1" dirty="0">
+                <a:solidFill>
+                  <a:schemeClr val="tx1"/>
+                </a:solidFill>
+                <a:latin typeface="+mj-lt" pitchFamily="34" charset="0"/>
+                <a:ea typeface="+mj-lt" pitchFamily="34" charset="-122"/>
+                <a:cs typeface="+mj-lt" pitchFamily="34" charset="-120"/>
+              </a:rPr>
+              <a:t>A child tells you that someone has been hurting them. What do you do first?</a:t>
+            </a:r>
+            <a:endParaRPr lang="en-US" sz="2200" dirty="0"/>
+          </a:p>
+        </p:txBody>
+      </p:sp>
+      <p:sp>
+        <p:nvSpPr>
+          <p:cNvPr id="6" name="Answer A">
+            <a:hlinkClick r:id="rId4" action="ppaction://hlinksldjump" tooltip="Answer A"/>
+          </p:cNvPr>
+          <p:cNvSpPr/>
+          <p:nvPr/>
+        </p:nvSpPr>
+        <p:spPr>
+          <a:xfrm>
+            <a:off x="457200" y="2148840"/>
+            <a:ext cx="8229600" cy="694944"/>
+          </a:xfrm>
+          <a:prstGeom prst="roundRect">
+            <a:avLst>
+              <a:gd name="adj" fmla="val 15789"/>
+            </a:avLst>
+          </a:prstGeom>
+          <a:solidFill>
+            <a:schemeClr val="bg1"/>
+          </a:solidFill>
+          <a:ln/>
+          <a:effectLst>
+            <a:outerShdw blurRad="101600" dist="25400" dir="5400000" algn="bl" rotWithShape="0">
+              <a:srgbClr val="1B2540">
+                <a:alpha val="14000"/>
+              </a:srgbClr>
+            </a:outerShdw>
+          </a:effectLst>
+        </p:spPr>
+        <p:txBody>
+          <a:bodyPr wrap="square" lIns="228600" tIns="0" rIns="152400" bIns="0" rtlCol="0" anchor="ctr"/>
+          <a:lstStyle/>
+          <a:p>
+            <a:pPr marL="0" indent="0" algn="l">
+              <a:buNone/>
+            </a:pPr>
+            <a:r>
+              <a:rPr lang="en-US" sz="2000" b="1" dirty="0">
+                <a:solidFill>
+                  <a:schemeClr val="accent1"/>
+                </a:solidFill>
+              </a:rPr>
+              <a:t>A    </a:t>
+            </a:r>
+            <a:r>
+              <a:rPr lang="en-US" sz="1600" dirty="0">
+                <a:solidFill>
+                  <a:schemeClr val="tx1"/>
+                </a:solidFill>
+              </a:rPr>
+              <a:t>Wait and see if it happens again</a:t>
+            </a:r>
+            <a:endParaRPr lang="en-US" sz="2000" dirty="0"/>
+          </a:p>
+        </p:txBody>
+      </p:sp>
+      <p:sp>
+        <p:nvSpPr>
+          <p:cNvPr id="7" name="Answer B">
+            <a:hlinkClick r:id="rId5" action="ppaction://hlinksldjump" tooltip="Answer B"/>
+          </p:cNvPr>
+          <p:cNvSpPr/>
+          <p:nvPr/>
+        </p:nvSpPr>
+        <p:spPr>
+          <a:xfrm>
+            <a:off x="457200" y="2953512"/>
+            <a:ext cx="8229600" cy="694944"/>
+          </a:xfrm>
+          <a:prstGeom prst="roundRect">
+            <a:avLst>
+              <a:gd name="adj" fmla="val 15789"/>
+            </a:avLst>
+          </a:prstGeom>
+          <a:solidFill>
+            <a:schemeClr val="bg1"/>
+          </a:solidFill>
+          <a:ln/>
+          <a:effectLst>
+            <a:outerShdw blurRad="101600" dist="25400" dir="5400000" algn="bl" rotWithShape="0">
+              <a:srgbClr val="1B2540">
+                <a:alpha val="14000"/>
+              </a:srgbClr>
+            </a:outerShdw>
+          </a:effectLst>
+        </p:spPr>
+        <p:txBody>
+          <a:bodyPr wrap="square" lIns="228600" tIns="0" rIns="152400" bIns="0" rtlCol="0" anchor="ctr"/>
+          <a:lstStyle/>
+          <a:p>
+            <a:pPr marL="0" indent="0" algn="l">
+              <a:buNone/>
+            </a:pPr>
+            <a:r>
+              <a:rPr lang="en-US" sz="2000" b="1" dirty="0">
+                <a:solidFill>
+                  <a:schemeClr val="accent1"/>
+                </a:solidFill>
+              </a:rPr>
+              <a:t>B    </a:t>
+            </a:r>
+            <a:r>
+              <a:rPr lang="en-US" sz="1600" dirty="0">
+                <a:solidFill>
+                  <a:schemeClr val="tx1"/>
+                </a:solidFill>
+              </a:rPr>
+              <a:t>Believe the child and thank them for the courage to tell</a:t>
+            </a:r>
+            <a:endParaRPr lang="en-US" sz="2000" dirty="0"/>
+          </a:p>
+        </p:txBody>
+      </p:sp>
+      <p:sp>
+        <p:nvSpPr>
+          <p:cNvPr id="8" name="Answer C">
+            <a:hlinkClick r:id="rId4" action="ppaction://hlinksldjump" tooltip="Answer C"/>
+          </p:cNvPr>
+          <p:cNvSpPr/>
+          <p:nvPr/>
+        </p:nvSpPr>
+        <p:spPr>
+          <a:xfrm>
+            <a:off x="457200" y="3758184"/>
+            <a:ext cx="8229600" cy="694944"/>
+          </a:xfrm>
+          <a:prstGeom prst="roundRect">
+            <a:avLst>
+              <a:gd name="adj" fmla="val 15789"/>
+            </a:avLst>
+          </a:prstGeom>
+          <a:solidFill>
+            <a:schemeClr val="bg1"/>
+          </a:solidFill>
+          <a:ln/>
+          <a:effectLst>
+            <a:outerShdw blurRad="101600" dist="25400" dir="5400000" algn="bl" rotWithShape="0">
+              <a:srgbClr val="1B2540">
+                <a:alpha val="14000"/>
+              </a:srgbClr>
+            </a:outerShdw>
+          </a:effectLst>
+        </p:spPr>
+        <p:txBody>
+          <a:bodyPr wrap="square" lIns="228600" tIns="0" rIns="152400" bIns="0" rtlCol="0" anchor="ctr"/>
+          <a:lstStyle/>
+          <a:p>
+            <a:pPr marL="0" indent="0" algn="l">
+              <a:buNone/>
+            </a:pPr>
+            <a:r>
+              <a:rPr lang="en-US" sz="2000" b="1" dirty="0">
+                <a:solidFill>
+                  <a:schemeClr val="accent1"/>
+                </a:solidFill>
+              </a:rPr>
+              <a:t>C    </a:t>
+            </a:r>
+            <a:r>
+              <a:rPr lang="en-US" sz="1600" dirty="0">
+                <a:solidFill>
+                  <a:schemeClr val="tx1"/>
+                </a:solidFill>
+              </a:rPr>
+              <a:t>Ask many detailed questions to confirm the story</a:t>
+            </a:r>
+            <a:endParaRPr lang="en-US" sz="2000" dirty="0"/>
           </a:p>
         </p:txBody>
       </p:sp>
@@ -6591,100 +6612,10 @@
           </a:prstGeom>
         </p:spPr>
       </p:pic>
-      <p:sp>
-        <p:nvSpPr>
-          <p:cNvPr id="19" name="Menu card Teen guidance">
-            <a:hlinkClick r:id="rId14" action="ppaction://hlinksldjump" tooltip="Open Teen guidance"/>
-          </p:cNvPr>
-          <p:cNvSpPr/>
-          <p:nvPr/>
-        </p:nvSpPr>
-        <p:spPr>
-          <a:xfrm>
-            <a:off x="6126480" y="2926080"/>
-            <a:ext cx="2560320" cy="1600200"/>
-          </a:xfrm>
-          <a:prstGeom prst="roundRect">
-            <a:avLst>
-              <a:gd name="adj" fmla="val 6857"/>
-            </a:avLst>
-          </a:prstGeom>
-          <a:solidFill>
-            <a:schemeClr val="bg1"/>
-          </a:solidFill>
-          <a:ln/>
-          <a:effectLst>
-            <a:outerShdw blurRad="101600" dist="25400" dir="5400000" algn="bl" rotWithShape="0">
-              <a:srgbClr val="1B2540">
-                <a:alpha val="14000"/>
-              </a:srgbClr>
-            </a:outerShdw>
-          </a:effectLst>
-        </p:spPr>
-        <p:txBody>
-          <a:bodyPr wrap="square" lIns="177800" tIns="0" rIns="152400" bIns="177800" rtlCol="0" anchor="b"/>
-          <a:lstStyle/>
-          <a:p>
-            <a:pPr marL="0" indent="0" algn="l">
-              <a:buNone/>
-            </a:pPr>
-            <a:r>
-              <a:rPr lang="en-US" sz="1800" b="1" dirty="0">
-                <a:solidFill>
-                  <a:schemeClr val="tx1"/>
-                </a:solidFill>
-              </a:rPr>
-              <a:t>Teen guidance</a:t>
-            </a:r>
-            <a:endParaRPr lang="en-US" sz="1800" dirty="0"/>
-          </a:p>
-          <a:p>
-            <a:pPr marL="0" indent="0" algn="l">
-              <a:buNone/>
-            </a:pPr>
-            <a:r>
-              <a:rPr lang="en-US" sz="1400" dirty="0">
-                <a:solidFill>
-                  <a:schemeClr val="tx2"/>
-                </a:solidFill>
-              </a:rPr>
-              <a:t>The HEEADSSS check-in</a:t>
-            </a:r>
-            <a:endParaRPr lang="en-US" sz="1800" dirty="0"/>
-          </a:p>
-        </p:txBody>
-      </p:sp>
-      <p:sp>
-        <p:nvSpPr>
-          <p:cNvPr id="20" name="Teen guidance circle">
-            <a:hlinkClick r:id="rId14" action="ppaction://hlinksldjump" tooltip="Open Teen guidance"/>
-          </p:cNvPr>
-          <p:cNvSpPr/>
-          <p:nvPr/>
-        </p:nvSpPr>
-        <p:spPr>
-          <a:xfrm>
-            <a:off x="6309360" y="3108960"/>
-            <a:ext cx="594360" cy="594360"/>
-          </a:xfrm>
-          <a:prstGeom prst="ellipse">
-            <a:avLst/>
-          </a:prstGeom>
-          <a:solidFill>
-            <a:schemeClr val="tx2"/>
-          </a:solidFill>
-          <a:ln w="12700">
-            <a:solidFill>
-              <a:schemeClr val="tx2"/>
-            </a:solidFill>
-            <a:prstDash val="solid"/>
-          </a:ln>
-        </p:spPr>
-      </p:sp>
       <p:pic>
         <p:nvPicPr>
           <p:cNvPr id="21" name="Teen guidance glyph" descr="Teen guidance">
-            <a:hlinkClick r:id="rId14" action="ppaction://hlinksldjump" tooltip="Open Teen guidance"/>
+            <a:hlinkClick r:id="rId3" action="ppaction://hlinksldjump" tooltip="Open Teen guidance"/>
           </p:cNvPr>
           <p:cNvPicPr>
             <a:picLocks noChangeAspect="1"/>
@@ -6692,7 +6623,7 @@
           <p:nvPr/>
         </p:nvPicPr>
         <p:blipFill>
-          <a:blip r:embed="rId15"/>
+          <a:blip r:embed="rId14"/>
           <a:stretch>
             <a:fillRect/>
           </a:stretch>
@@ -6752,359 +6683,6 @@
 </file>
 
 <file path=ppt/slides/slide20.xml><?xml version="1.0" encoding="utf-8"?>
-<p:sld xmlns:a="http://schemas.openxmlformats.org/drawingml/2006/main" xmlns:r="http://schemas.openxmlformats.org/officeDocument/2006/relationships" xmlns:p="http://schemas.openxmlformats.org/presentationml/2006/main">
-  <p:cSld name="Slide 20">
-    <p:spTree>
-      <p:nvGrpSpPr>
-        <p:cNvPr id="1" name=""/>
-        <p:cNvGrpSpPr/>
-        <p:nvPr/>
-      </p:nvGrpSpPr>
-      <p:grpSpPr>
-        <a:xfrm>
-          <a:off x="0" y="0"/>
-          <a:ext cx="0" cy="0"/>
-          <a:chOff x="0" y="0"/>
-          <a:chExt cx="0" cy="0"/>
-        </a:xfrm>
-      </p:grpSpPr>
-      <p:sp>
-        <p:nvSpPr>
-          <p:cNvPr id="2" name="Text 0"/>
-          <p:cNvSpPr>
-            <a:spLocks noGrp="1"/>
-          </p:cNvSpPr>
-          <p:nvPr>
-            <p:ph type="title" idx="100" hasCustomPrompt="1"/>
-          </p:nvPr>
-        </p:nvSpPr>
-        <p:spPr>
-          <a:xfrm>
-            <a:off x="457200" y="274320"/>
-            <a:ext cx="6949440" cy="640080"/>
-          </a:xfrm>
-          <a:prstGeom prst="rect">
-            <a:avLst/>
-          </a:prstGeom>
-          <a:noFill/>
-          <a:ln/>
-        </p:spPr>
-        <p:txBody>
-          <a:bodyPr wrap="square" lIns="0" tIns="0" rIns="0" bIns="0" rtlCol="0" anchor="ctr"/>
-          <a:lstStyle/>
-          <a:p>
-            <a:pPr marL="0" indent="0" algn="l">
-              <a:buNone/>
-            </a:pPr>
-            <a:r>
-              <a:rPr lang="en-US" sz="3000" b="1" dirty="0">
-                <a:solidFill>
-                  <a:schemeClr val="tx1"/>
-                </a:solidFill>
-              </a:rPr>
-              <a:t>Question 4 of 4</a:t>
-            </a:r>
-            <a:endParaRPr lang="en-US" sz="3000" dirty="0"/>
-          </a:p>
-        </p:txBody>
-      </p:sp>
-      <p:sp>
-        <p:nvSpPr>
-          <p:cNvPr id="3" name="Menu button">
-            <a:hlinkClick r:id="rId3" action="ppaction://hlinksldjump" tooltip="Back to the topic menu"/>
-          </p:cNvPr>
-          <p:cNvSpPr/>
-          <p:nvPr/>
-        </p:nvSpPr>
-        <p:spPr>
-          <a:xfrm>
-            <a:off x="7635240" y="365760"/>
-            <a:ext cx="1051560" cy="365760"/>
-          </a:xfrm>
-          <a:prstGeom prst="roundRect">
-            <a:avLst>
-              <a:gd name="adj" fmla="val 50000"/>
-            </a:avLst>
-          </a:prstGeom>
-          <a:solidFill>
-            <a:schemeClr val="tx1"/>
-          </a:solidFill>
-          <a:ln/>
-        </p:spPr>
-        <p:txBody>
-          <a:bodyPr wrap="square" lIns="0" tIns="0" rIns="0" bIns="0" rtlCol="0" anchor="ctr"/>
-          <a:lstStyle/>
-          <a:p>
-            <a:pPr marL="0" indent="0" algn="ctr">
-              <a:buNone/>
-            </a:pPr>
-            <a:r>
-              <a:rPr lang="en-US" sz="1400" b="1" dirty="0">
-                <a:solidFill>
-                  <a:schemeClr val="bg1"/>
-                </a:solidFill>
-              </a:rPr>
-              <a:t>Menu</a:t>
-            </a:r>
-            <a:endParaRPr lang="en-US" sz="1400" dirty="0"/>
-          </a:p>
-        </p:txBody>
-      </p:sp>
-      <p:sp>
-        <p:nvSpPr>
-          <p:cNvPr id="4" name="Topic label"/>
-          <p:cNvSpPr txBox="1"/>
-          <p:nvPr/>
-        </p:nvSpPr>
-        <p:spPr>
-          <a:xfrm>
-            <a:off x="457200" y="896112"/>
-            <a:ext cx="5486400" cy="274320"/>
-          </a:xfrm>
-          <a:prstGeom prst="rect">
-            <a:avLst/>
-          </a:prstGeom>
-          <a:noFill/>
-          <a:ln/>
-        </p:spPr>
-        <p:txBody>
-          <a:bodyPr wrap="square" lIns="0" tIns="0" rIns="0" bIns="0" rtlCol="0" anchor="ctr"/>
-          <a:lstStyle/>
-          <a:p>
-            <a:pPr marL="0" indent="0">
-              <a:buNone/>
-            </a:pPr>
-            <a:r>
-              <a:rPr lang="en-US" sz="1200" b="1" kern="0" spc="200" dirty="0">
-                <a:solidFill>
-                  <a:schemeClr val="accent1"/>
-                </a:solidFill>
-              </a:rPr>
-              <a:t>CHILD PROTECTION</a:t>
-            </a:r>
-            <a:endParaRPr lang="en-US" sz="1200" dirty="0"/>
-          </a:p>
-        </p:txBody>
-      </p:sp>
-      <p:sp>
-        <p:nvSpPr>
-          <p:cNvPr id="5" name="Question"/>
-          <p:cNvSpPr txBox="1"/>
-          <p:nvPr/>
-        </p:nvSpPr>
-        <p:spPr>
-          <a:xfrm>
-            <a:off x="457200" y="1188720"/>
-            <a:ext cx="8229600" cy="822960"/>
-          </a:xfrm>
-          <a:prstGeom prst="rect">
-            <a:avLst/>
-          </a:prstGeom>
-          <a:noFill/>
-          <a:ln/>
-        </p:spPr>
-        <p:txBody>
-          <a:bodyPr wrap="square" lIns="0" tIns="0" rIns="0" bIns="0" rtlCol="0" anchor="t"/>
-          <a:lstStyle/>
-          <a:p>
-            <a:pPr marL="0" indent="0">
-              <a:buNone/>
-            </a:pPr>
-            <a:r>
-              <a:rPr lang="en-US" sz="2200" b="1" dirty="0">
-                <a:solidFill>
-                  <a:schemeClr val="tx1"/>
-                </a:solidFill>
-                <a:latin typeface="+mj-lt" pitchFamily="34" charset="0"/>
-                <a:ea typeface="+mj-lt" pitchFamily="34" charset="-122"/>
-                <a:cs typeface="+mj-lt" pitchFamily="34" charset="-120"/>
-              </a:rPr>
-              <a:t>A child tells you that someone has been hurting them. What do you do first?</a:t>
-            </a:r>
-            <a:endParaRPr lang="en-US" sz="2200" dirty="0"/>
-          </a:p>
-        </p:txBody>
-      </p:sp>
-      <p:sp>
-        <p:nvSpPr>
-          <p:cNvPr id="6" name="Answer A">
-            <a:hlinkClick r:id="rId4" action="ppaction://hlinksldjump" tooltip="Answer A"/>
-          </p:cNvPr>
-          <p:cNvSpPr/>
-          <p:nvPr/>
-        </p:nvSpPr>
-        <p:spPr>
-          <a:xfrm>
-            <a:off x="457200" y="2148840"/>
-            <a:ext cx="8229600" cy="694944"/>
-          </a:xfrm>
-          <a:prstGeom prst="roundRect">
-            <a:avLst>
-              <a:gd name="adj" fmla="val 15789"/>
-            </a:avLst>
-          </a:prstGeom>
-          <a:solidFill>
-            <a:schemeClr val="bg1"/>
-          </a:solidFill>
-          <a:ln/>
-          <a:effectLst>
-            <a:outerShdw blurRad="101600" dist="25400" dir="5400000" algn="bl" rotWithShape="0">
-              <a:srgbClr val="1B2540">
-                <a:alpha val="14000"/>
-              </a:srgbClr>
-            </a:outerShdw>
-          </a:effectLst>
-        </p:spPr>
-        <p:txBody>
-          <a:bodyPr wrap="square" lIns="228600" tIns="0" rIns="152400" bIns="0" rtlCol="0" anchor="ctr"/>
-          <a:lstStyle/>
-          <a:p>
-            <a:pPr marL="0" indent="0" algn="l">
-              <a:buNone/>
-            </a:pPr>
-            <a:r>
-              <a:rPr lang="en-US" sz="2000" b="1" dirty="0">
-                <a:solidFill>
-                  <a:schemeClr val="accent1"/>
-                </a:solidFill>
-              </a:rPr>
-              <a:t>A    </a:t>
-            </a:r>
-            <a:r>
-              <a:rPr lang="en-US" sz="1600" dirty="0">
-                <a:solidFill>
-                  <a:schemeClr val="tx1"/>
-                </a:solidFill>
-              </a:rPr>
-              <a:t>Wait and see if it happens again</a:t>
-            </a:r>
-            <a:endParaRPr lang="en-US" sz="2000" dirty="0"/>
-          </a:p>
-        </p:txBody>
-      </p:sp>
-      <p:sp>
-        <p:nvSpPr>
-          <p:cNvPr id="7" name="Answer B">
-            <a:hlinkClick r:id="rId5" action="ppaction://hlinksldjump" tooltip="Answer B"/>
-          </p:cNvPr>
-          <p:cNvSpPr/>
-          <p:nvPr/>
-        </p:nvSpPr>
-        <p:spPr>
-          <a:xfrm>
-            <a:off x="457200" y="2953512"/>
-            <a:ext cx="8229600" cy="694944"/>
-          </a:xfrm>
-          <a:prstGeom prst="roundRect">
-            <a:avLst>
-              <a:gd name="adj" fmla="val 15789"/>
-            </a:avLst>
-          </a:prstGeom>
-          <a:solidFill>
-            <a:schemeClr val="bg1"/>
-          </a:solidFill>
-          <a:ln/>
-          <a:effectLst>
-            <a:outerShdw blurRad="101600" dist="25400" dir="5400000" algn="bl" rotWithShape="0">
-              <a:srgbClr val="1B2540">
-                <a:alpha val="14000"/>
-              </a:srgbClr>
-            </a:outerShdw>
-          </a:effectLst>
-        </p:spPr>
-        <p:txBody>
-          <a:bodyPr wrap="square" lIns="228600" tIns="0" rIns="152400" bIns="0" rtlCol="0" anchor="ctr"/>
-          <a:lstStyle/>
-          <a:p>
-            <a:pPr marL="0" indent="0" algn="l">
-              <a:buNone/>
-            </a:pPr>
-            <a:r>
-              <a:rPr lang="en-US" sz="2000" b="1" dirty="0">
-                <a:solidFill>
-                  <a:schemeClr val="accent1"/>
-                </a:solidFill>
-              </a:rPr>
-              <a:t>B    </a:t>
-            </a:r>
-            <a:r>
-              <a:rPr lang="en-US" sz="1600" dirty="0">
-                <a:solidFill>
-                  <a:schemeClr val="tx1"/>
-                </a:solidFill>
-              </a:rPr>
-              <a:t>Believe the child and thank them for the courage to tell</a:t>
-            </a:r>
-            <a:endParaRPr lang="en-US" sz="2000" dirty="0"/>
-          </a:p>
-        </p:txBody>
-      </p:sp>
-      <p:sp>
-        <p:nvSpPr>
-          <p:cNvPr id="8" name="Answer C">
-            <a:hlinkClick r:id="rId4" action="ppaction://hlinksldjump" tooltip="Answer C"/>
-          </p:cNvPr>
-          <p:cNvSpPr/>
-          <p:nvPr/>
-        </p:nvSpPr>
-        <p:spPr>
-          <a:xfrm>
-            <a:off x="457200" y="3758184"/>
-            <a:ext cx="8229600" cy="694944"/>
-          </a:xfrm>
-          <a:prstGeom prst="roundRect">
-            <a:avLst>
-              <a:gd name="adj" fmla="val 15789"/>
-            </a:avLst>
-          </a:prstGeom>
-          <a:solidFill>
-            <a:schemeClr val="bg1"/>
-          </a:solidFill>
-          <a:ln/>
-          <a:effectLst>
-            <a:outerShdw blurRad="101600" dist="25400" dir="5400000" algn="bl" rotWithShape="0">
-              <a:srgbClr val="1B2540">
-                <a:alpha val="14000"/>
-              </a:srgbClr>
-            </a:outerShdw>
-          </a:effectLst>
-        </p:spPr>
-        <p:txBody>
-          <a:bodyPr wrap="square" lIns="228600" tIns="0" rIns="152400" bIns="0" rtlCol="0" anchor="ctr"/>
-          <a:lstStyle/>
-          <a:p>
-            <a:pPr marL="0" indent="0" algn="l">
-              <a:buNone/>
-            </a:pPr>
-            <a:r>
-              <a:rPr lang="en-US" sz="2000" b="1" dirty="0">
-                <a:solidFill>
-                  <a:schemeClr val="accent1"/>
-                </a:solidFill>
-              </a:rPr>
-              <a:t>C    </a:t>
-            </a:r>
-            <a:r>
-              <a:rPr lang="en-US" sz="1600" dirty="0">
-                <a:solidFill>
-                  <a:schemeClr val="tx1"/>
-                </a:solidFill>
-              </a:rPr>
-              <a:t>Ask many detailed questions to confirm the story</a:t>
-            </a:r>
-            <a:endParaRPr lang="en-US" sz="2000" dirty="0"/>
-          </a:p>
-        </p:txBody>
-      </p:sp>
-    </p:spTree>
-  </p:cSld>
-  <p:clrMapOvr>
-    <a:masterClrMapping/>
-  </p:clrMapOvr>
-</p:sld>
-</file>
-
-<file path=ppt/slides/slide21.xml><?xml version="1.0" encoding="utf-8"?>
 <p:sld xmlns:a="http://schemas.openxmlformats.org/drawingml/2006/main" xmlns:r="http://schemas.openxmlformats.org/officeDocument/2006/relationships" xmlns:p="http://schemas.openxmlformats.org/presentationml/2006/main">
   <p:cSld name="Slide 21">
     <p:spTree>
@@ -7377,7 +6955,7 @@
 </p:sld>
 </file>
 
-<file path=ppt/slides/slide22.xml><?xml version="1.0" encoding="utf-8"?>
+<file path=ppt/slides/slide21.xml><?xml version="1.0" encoding="utf-8"?>
 <p:sld xmlns:a="http://schemas.openxmlformats.org/drawingml/2006/main" xmlns:r="http://schemas.openxmlformats.org/officeDocument/2006/relationships" xmlns:p="http://schemas.openxmlformats.org/presentationml/2006/main">
   <p:cSld name="Slide 22">
     <p:spTree>
@@ -7637,6 +7215,308 @@
                 </a:solidFill>
               </a:rPr>
               <a:t>Menu</a:t>
+            </a:r>
+            <a:endParaRPr lang="en-US" sz="1400" dirty="0"/>
+          </a:p>
+        </p:txBody>
+      </p:sp>
+    </p:spTree>
+  </p:cSld>
+  <p:clrMapOvr>
+    <a:masterClrMapping/>
+  </p:clrMapOvr>
+</p:sld>
+</file>
+
+<file path=ppt/slides/slide22.xml><?xml version="1.0" encoding="utf-8"?>
+<p:sld xmlns:a="http://schemas.openxmlformats.org/drawingml/2006/main" xmlns:r="http://schemas.openxmlformats.org/officeDocument/2006/relationships" xmlns:p="http://schemas.openxmlformats.org/presentationml/2006/main">
+  <p:cSld name="Slide 23">
+    <p:spTree>
+      <p:nvGrpSpPr>
+        <p:cNvPr id="1" name=""/>
+        <p:cNvGrpSpPr/>
+        <p:nvPr/>
+      </p:nvGrpSpPr>
+      <p:grpSpPr>
+        <a:xfrm>
+          <a:off x="0" y="0"/>
+          <a:ext cx="0" cy="0"/>
+          <a:chOff x="0" y="0"/>
+          <a:chExt cx="0" cy="0"/>
+        </a:xfrm>
+      </p:grpSpPr>
+      <p:pic>
+        <p:nvPicPr>
+          <p:cNvPr id="2" name="Family photo" descr="Silhouette of two parents swinging a child between them in a sunny field"/>
+          <p:cNvPicPr>
+            <a:picLocks noChangeAspect="1"/>
+          </p:cNvPicPr>
+          <p:nvPr/>
+        </p:nvPicPr>
+        <p:blipFill>
+          <a:blip r:embed="rId3"/>
+          <a:stretch>
+            <a:fillRect/>
+          </a:stretch>
+        </p:blipFill>
+        <p:spPr>
+          <a:xfrm>
+            <a:off x="4937760" y="0"/>
+            <a:ext cx="4206240" cy="5143500"/>
+          </a:xfrm>
+          <a:prstGeom prst="rect">
+            <a:avLst/>
+          </a:prstGeom>
+        </p:spPr>
+      </p:pic>
+      <p:sp>
+        <p:nvSpPr>
+          <p:cNvPr id="3" name="Eyebrow"/>
+          <p:cNvSpPr txBox="1"/>
+          <p:nvPr/>
+        </p:nvSpPr>
+        <p:spPr>
+          <a:xfrm>
+            <a:off x="548640" y="640080"/>
+            <a:ext cx="4023360" cy="320040"/>
+          </a:xfrm>
+          <a:prstGeom prst="rect">
+            <a:avLst/>
+          </a:prstGeom>
+          <a:noFill/>
+          <a:ln/>
+        </p:spPr>
+        <p:txBody>
+          <a:bodyPr wrap="square" lIns="0" tIns="0" rIns="0" bIns="0" rtlCol="0" anchor="ctr"/>
+          <a:lstStyle/>
+          <a:p>
+            <a:pPr marL="0" indent="0">
+              <a:buNone/>
+            </a:pPr>
+            <a:r>
+              <a:rPr lang="en-US" sz="1400" b="1" kern="0" spc="400" dirty="0">
+                <a:solidFill>
+                  <a:schemeClr val="accent3"/>
+                </a:solidFill>
+              </a:rPr>
+              <a:t>WELL DONE</a:t>
+            </a:r>
+            <a:endParaRPr lang="en-US" sz="1400" dirty="0"/>
+          </a:p>
+        </p:txBody>
+      </p:sp>
+      <p:sp>
+        <p:nvSpPr>
+          <p:cNvPr id="4" name="Closing title"/>
+          <p:cNvSpPr txBox="1"/>
+          <p:nvPr/>
+        </p:nvSpPr>
+        <p:spPr>
+          <a:xfrm>
+            <a:off x="548640" y="1005840"/>
+            <a:ext cx="4114800" cy="1188720"/>
+          </a:xfrm>
+          <a:prstGeom prst="rect">
+            <a:avLst/>
+          </a:prstGeom>
+          <a:noFill/>
+          <a:ln/>
+        </p:spPr>
+        <p:txBody>
+          <a:bodyPr wrap="square" lIns="0" tIns="0" rIns="0" bIns="0" rtlCol="0" anchor="t"/>
+          <a:lstStyle/>
+          <a:p>
+            <a:pPr marL="0" indent="0">
+              <a:buNone/>
+            </a:pPr>
+            <a:r>
+              <a:rPr lang="en-US" sz="3400" b="1" dirty="0">
+                <a:solidFill>
+                  <a:schemeClr val="bg1"/>
+                </a:solidFill>
+                <a:latin typeface="+mj-lt" pitchFamily="34" charset="0"/>
+                <a:ea typeface="+mj-lt" pitchFamily="34" charset="-122"/>
+                <a:cs typeface="+mj-lt" pitchFamily="34" charset="-120"/>
+              </a:rPr>
+              <a:t>Small habits, big futures</a:t>
+            </a:r>
+            <a:endParaRPr lang="en-US" sz="3400" dirty="0"/>
+          </a:p>
+        </p:txBody>
+      </p:sp>
+      <p:sp>
+        <p:nvSpPr>
+          <p:cNvPr id="5" name="Takeaways"/>
+          <p:cNvSpPr txBox="1"/>
+          <p:nvPr/>
+        </p:nvSpPr>
+        <p:spPr>
+          <a:xfrm>
+            <a:off x="548640" y="2286000"/>
+            <a:ext cx="4114800" cy="1645920"/>
+          </a:xfrm>
+          <a:prstGeom prst="rect">
+            <a:avLst/>
+          </a:prstGeom>
+          <a:noFill/>
+          <a:ln/>
+        </p:spPr>
+        <p:txBody>
+          <a:bodyPr wrap="square" lIns="0" tIns="0" rIns="0" bIns="0" rtlCol="0" anchor="t"/>
+          <a:lstStyle/>
+          <a:p>
+            <a:pPr marL="177800" indent="-177800">
+              <a:spcAft>
+                <a:spcPts val="800"/>
+              </a:spcAft>
+              <a:buSzPct val="100000"/>
+              <a:buChar char="•"/>
+            </a:pPr>
+            <a:r>
+              <a:rPr lang="en-US" sz="1600" dirty="0">
+                <a:solidFill>
+                  <a:schemeClr val="bg1"/>
+                </a:solidFill>
+              </a:rPr>
+              <a:t>Start strong: dry, skin to skin, stay together</a:t>
+            </a:r>
+            <a:endParaRPr lang="en-US" sz="1600" dirty="0"/>
+          </a:p>
+          <a:p>
+            <a:pPr marL="177800" indent="-177800">
+              <a:spcAft>
+                <a:spcPts val="800"/>
+              </a:spcAft>
+              <a:buSzPct val="100000"/>
+              <a:buChar char="•"/>
+            </a:pPr>
+            <a:r>
+              <a:rPr lang="en-US" sz="1600" dirty="0">
+                <a:solidFill>
+                  <a:schemeClr val="bg1"/>
+                </a:solidFill>
+              </a:rPr>
+              <a:t>Use a good latch, store milk safely</a:t>
+            </a:r>
+            <a:endParaRPr lang="en-US" sz="1600" dirty="0"/>
+          </a:p>
+          <a:p>
+            <a:pPr marL="177800" indent="-177800">
+              <a:spcAft>
+                <a:spcPts val="800"/>
+              </a:spcAft>
+              <a:buSzPct val="100000"/>
+              <a:buChar char="•"/>
+            </a:pPr>
+            <a:r>
+              <a:rPr lang="en-US" sz="1600" dirty="0">
+                <a:solidFill>
+                  <a:schemeClr val="bg1"/>
+                </a:solidFill>
+              </a:rPr>
+              <a:t>Read aloud every day</a:t>
+            </a:r>
+            <a:endParaRPr lang="en-US" sz="1600" dirty="0"/>
+          </a:p>
+          <a:p>
+            <a:pPr marL="177800" indent="-177800">
+              <a:spcAft>
+                <a:spcPts val="800"/>
+              </a:spcAft>
+              <a:buSzPct val="100000"/>
+              <a:buChar char="•"/>
+            </a:pPr>
+            <a:r>
+              <a:rPr lang="en-US" sz="1600" dirty="0">
+                <a:solidFill>
+                  <a:schemeClr val="bg1"/>
+                </a:solidFill>
+              </a:rPr>
+              <a:t>Always believe a child who tells you</a:t>
+            </a:r>
+            <a:endParaRPr lang="en-US" sz="1600" dirty="0"/>
+          </a:p>
+        </p:txBody>
+      </p:sp>
+      <p:sp>
+        <p:nvSpPr>
+          <p:cNvPr id="6" name="Menu button">
+            <a:hlinkClick r:id="rId4" action="ppaction://hlinksldjump" tooltip="Open the topic menu"/>
+          </p:cNvPr>
+          <p:cNvSpPr/>
+          <p:nvPr/>
+        </p:nvSpPr>
+        <p:spPr>
+          <a:xfrm>
+            <a:off x="548640" y="4160520"/>
+            <a:ext cx="1828800" cy="420624"/>
+          </a:xfrm>
+          <a:prstGeom prst="roundRect">
+            <a:avLst>
+              <a:gd name="adj" fmla="val 50000"/>
+            </a:avLst>
+          </a:prstGeom>
+          <a:solidFill>
+            <a:schemeClr val="accent3"/>
+          </a:solidFill>
+          <a:ln/>
+        </p:spPr>
+        <p:txBody>
+          <a:bodyPr wrap="square" lIns="0" tIns="0" rIns="0" bIns="0" rtlCol="0" anchor="ctr"/>
+          <a:lstStyle/>
+          <a:p>
+            <a:pPr marL="0" indent="0" algn="ctr">
+              <a:buNone/>
+            </a:pPr>
+            <a:r>
+              <a:rPr lang="en-US" sz="1400" b="1" dirty="0">
+                <a:solidFill>
+                  <a:schemeClr val="tx1"/>
+                </a:solidFill>
+              </a:rPr>
+              <a:t>Back to menu</a:t>
+            </a:r>
+            <a:endParaRPr lang="en-US" sz="1400" dirty="0"/>
+          </a:p>
+        </p:txBody>
+      </p:sp>
+      <p:sp>
+        <p:nvSpPr>
+          <p:cNvPr id="7" name="Retake button">
+            <a:hlinkClick r:id="rId5" action="ppaction://hlinksldjump" tooltip="Restart the quiz"/>
+          </p:cNvPr>
+          <p:cNvSpPr/>
+          <p:nvPr/>
+        </p:nvSpPr>
+        <p:spPr>
+          <a:xfrm>
+            <a:off x="2560320" y="4160520"/>
+            <a:ext cx="1645920" cy="420624"/>
+          </a:xfrm>
+          <a:prstGeom prst="roundRect">
+            <a:avLst>
+              <a:gd name="adj" fmla="val 50000"/>
+            </a:avLst>
+          </a:prstGeom>
+          <a:solidFill>
+            <a:schemeClr val="tx2"/>
+          </a:solidFill>
+          <a:ln/>
+        </p:spPr>
+        <p:txBody>
+          <a:bodyPr wrap="square" lIns="0" tIns="0" rIns="0" bIns="0" rtlCol="0" anchor="ctr"/>
+          <a:lstStyle/>
+          <a:p>
+            <a:pPr marL="0" indent="0" algn="ctr">
+              <a:buNone/>
+            </a:pPr>
+            <a:r>
+              <a:rPr lang="en-US" sz="1400" b="1" dirty="0">
+                <a:solidFill>
+                  <a:schemeClr val="bg1"/>
+                </a:solidFill>
+              </a:rPr>
+              <a:t>Retake quiz</a:t>
             </a:r>
             <a:endParaRPr lang="en-US" sz="1400" dirty="0"/>
           </a:p>
@@ -7667,24 +7547,106 @@
           <a:chExt cx="0" cy="0"/>
         </a:xfrm>
       </p:grpSpPr>
+      <p:sp>
+        <p:nvSpPr>
+          <p:cNvPr id="2" name="Text 0"/>
+          <p:cNvSpPr>
+            <a:spLocks noGrp="1"/>
+          </p:cNvSpPr>
+          <p:nvPr>
+            <p:ph type="title" idx="100" hasCustomPrompt="1"/>
+          </p:nvPr>
+        </p:nvSpPr>
+        <p:spPr>
+          <a:xfrm>
+            <a:off x="457200" y="274320"/>
+            <a:ext cx="6949440" cy="640080"/>
+          </a:xfrm>
+          <a:prstGeom prst="rect">
+            <a:avLst/>
+          </a:prstGeom>
+          <a:noFill/>
+          <a:ln/>
+        </p:spPr>
+        <p:txBody>
+          <a:bodyPr wrap="square" lIns="0" tIns="0" rIns="0" bIns="0" rtlCol="0" anchor="ctr"/>
+          <a:lstStyle/>
+          <a:p>
+            <a:pPr marL="0" indent="0" algn="l">
+              <a:buNone/>
+            </a:pPr>
+            <a:r>
+              <a:rPr lang="en-US" sz="3000" b="1" dirty="0">
+                <a:solidFill>
+                  <a:schemeClr val="tx1"/>
+                </a:solidFill>
+              </a:rPr>
+              <a:t>Good latch: watch the video</a:t>
+            </a:r>
+            <a:endParaRPr lang="en-US" sz="3000" dirty="0"/>
+          </a:p>
+        </p:txBody>
+      </p:sp>
+      <p:sp>
+        <p:nvSpPr>
+          <p:cNvPr id="3" name="Menu button">
+            <a:hlinkClick r:id="rId2" action="ppaction://hlinksldjump" tooltip="Back to the topic menu"/>
+          </p:cNvPr>
+          <p:cNvSpPr/>
+          <p:nvPr/>
+        </p:nvSpPr>
+        <p:spPr>
+          <a:xfrm>
+            <a:off x="7635240" y="365760"/>
+            <a:ext cx="1051560" cy="365760"/>
+          </a:xfrm>
+          <a:prstGeom prst="roundRect">
+            <a:avLst>
+              <a:gd name="adj" fmla="val 50000"/>
+            </a:avLst>
+          </a:prstGeom>
+          <a:solidFill>
+            <a:schemeClr val="tx1"/>
+          </a:solidFill>
+          <a:ln/>
+        </p:spPr>
+        <p:txBody>
+          <a:bodyPr wrap="square" lIns="0" tIns="0" rIns="0" bIns="0" rtlCol="0" anchor="ctr"/>
+          <a:lstStyle/>
+          <a:p>
+            <a:pPr marL="0" indent="0" algn="ctr">
+              <a:buNone/>
+            </a:pPr>
+            <a:r>
+              <a:rPr lang="en-US" sz="1400" b="1" dirty="0">
+                <a:solidFill>
+                  <a:schemeClr val="bg1"/>
+                </a:solidFill>
+              </a:rPr>
+              <a:t>Menu</a:t>
+            </a:r>
+            <a:endParaRPr lang="en-US" sz="1400" dirty="0"/>
+          </a:p>
+        </p:txBody>
+      </p:sp>
       <p:pic>
         <p:nvPicPr>
-          <p:cNvPr id="2" name="Family photo" descr="Silhouette of two parents swinging a child between them in a sunny field"/>
-          <p:cNvPicPr>
-            <a:picLocks noChangeAspect="1"/>
-          </p:cNvPicPr>
-          <p:nvPr/>
+          <p:cNvPr id="6" name="Latch video" descr="Video: how to get a good latch"/>
+          <p:cNvPicPr/>
+          <p:nvPr>
+            <a:videoFile r:link="rId5"/>
+          </p:nvPr>
         </p:nvPicPr>
         <p:blipFill>
-          <a:blip r:embed="rId3"/>
+          <a:blip r:embed="rId6"/>
           <a:stretch>
             <a:fillRect/>
           </a:stretch>
         </p:blipFill>
         <p:spPr>
           <a:xfrm>
-            <a:off x="4937760" y="0"/>
-            <a:ext cx="4206240" cy="5143500"/>
+            <a:off x="1874519" y="1005840"/>
+            <a:ext cx="5394960" cy="3034893"/>
           </a:xfrm>
           <a:prstGeom prst="rect">
             <a:avLst/>
@@ -7693,185 +7655,50 @@
       </p:pic>
       <p:sp>
         <p:nvSpPr>
-          <p:cNvPr id="3" name="Eyebrow"/>
+          <p:cNvPr id="7" name="Video note"/>
           <p:cNvSpPr txBox="1"/>
           <p:nvPr/>
         </p:nvSpPr>
         <p:spPr>
           <a:xfrm>
-            <a:off x="548640" y="640080"/>
-            <a:ext cx="4023360" cy="320040"/>
+            <a:off x="914400" y="4160520"/>
+            <a:ext cx="7315200" cy="365760"/>
           </a:xfrm>
           <a:prstGeom prst="rect">
             <a:avLst/>
           </a:prstGeom>
           <a:noFill/>
-          <a:ln/>
-        </p:spPr>
-        <p:txBody>
-          <a:bodyPr wrap="square" lIns="0" tIns="0" rIns="0" bIns="0" rtlCol="0" anchor="ctr"/>
-          <a:lstStyle/>
-          <a:p>
-            <a:pPr marL="0" indent="0">
-              <a:buNone/>
-            </a:pPr>
-            <a:r>
-              <a:rPr lang="en-US" sz="1400" b="1" kern="0" spc="400" dirty="0">
-                <a:solidFill>
-                  <a:schemeClr val="accent3"/>
-                </a:solidFill>
-              </a:rPr>
-              <a:t>WELL DONE</a:t>
-            </a:r>
-            <a:endParaRPr lang="en-US" sz="1400" dirty="0"/>
-          </a:p>
-        </p:txBody>
-      </p:sp>
-      <p:sp>
-        <p:nvSpPr>
-          <p:cNvPr id="4" name="Closing title"/>
-          <p:cNvSpPr txBox="1"/>
-          <p:nvPr/>
-        </p:nvSpPr>
-        <p:spPr>
-          <a:xfrm>
-            <a:off x="548640" y="1005840"/>
-            <a:ext cx="4114800" cy="1188720"/>
-          </a:xfrm>
-          <a:prstGeom prst="rect">
-            <a:avLst/>
-          </a:prstGeom>
-          <a:noFill/>
-          <a:ln/>
-        </p:spPr>
-        <p:txBody>
-          <a:bodyPr wrap="square" lIns="0" tIns="0" rIns="0" bIns="0" rtlCol="0" anchor="t"/>
-          <a:lstStyle/>
-          <a:p>
-            <a:pPr marL="0" indent="0">
-              <a:buNone/>
-            </a:pPr>
-            <a:r>
-              <a:rPr lang="en-US" sz="3400" b="1" dirty="0">
-                <a:solidFill>
-                  <a:schemeClr val="bg1"/>
-                </a:solidFill>
-                <a:latin typeface="+mj-lt" pitchFamily="34" charset="0"/>
-                <a:ea typeface="+mj-lt" pitchFamily="34" charset="-122"/>
-                <a:cs typeface="+mj-lt" pitchFamily="34" charset="-120"/>
-              </a:rPr>
-              <a:t>Small habits, big futures</a:t>
-            </a:r>
-            <a:endParaRPr lang="en-US" sz="3400" dirty="0"/>
-          </a:p>
-        </p:txBody>
-      </p:sp>
-      <p:sp>
-        <p:nvSpPr>
-          <p:cNvPr id="5" name="Takeaways"/>
-          <p:cNvSpPr txBox="1"/>
-          <p:nvPr/>
-        </p:nvSpPr>
-        <p:spPr>
-          <a:xfrm>
-            <a:off x="548640" y="2286000"/>
-            <a:ext cx="4114800" cy="1645920"/>
-          </a:xfrm>
-          <a:prstGeom prst="rect">
-            <a:avLst/>
-          </a:prstGeom>
-          <a:noFill/>
-          <a:ln/>
-        </p:spPr>
-        <p:txBody>
-          <a:bodyPr wrap="square" lIns="0" tIns="0" rIns="0" bIns="0" rtlCol="0" anchor="t"/>
-          <a:lstStyle/>
-          <a:p>
-            <a:pPr marL="177800" indent="-177800">
-              <a:spcAft>
-                <a:spcPts val="800"/>
-              </a:spcAft>
-              <a:buSzPct val="100000"/>
-              <a:buChar char="•"/>
-            </a:pPr>
-            <a:r>
-              <a:rPr lang="en-US" sz="1600" dirty="0">
-                <a:solidFill>
-                  <a:schemeClr val="bg1"/>
-                </a:solidFill>
-              </a:rPr>
-              <a:t>Start strong: dry, skin to skin, stay together</a:t>
-            </a:r>
-            <a:endParaRPr lang="en-US" sz="1600" dirty="0"/>
-          </a:p>
-          <a:p>
-            <a:pPr marL="177800" indent="-177800">
-              <a:spcAft>
-                <a:spcPts val="800"/>
-              </a:spcAft>
-              <a:buSzPct val="100000"/>
-              <a:buChar char="•"/>
-            </a:pPr>
-            <a:r>
-              <a:rPr lang="en-US" sz="1600" dirty="0">
-                <a:solidFill>
-                  <a:schemeClr val="bg1"/>
-                </a:solidFill>
-              </a:rPr>
-              <a:t>Use a good latch, store milk safely</a:t>
-            </a:r>
-            <a:endParaRPr lang="en-US" sz="1600" dirty="0"/>
-          </a:p>
-          <a:p>
-            <a:pPr marL="177800" indent="-177800">
-              <a:spcAft>
-                <a:spcPts val="800"/>
-              </a:spcAft>
-              <a:buSzPct val="100000"/>
-              <a:buChar char="•"/>
-            </a:pPr>
-            <a:r>
-              <a:rPr lang="en-US" sz="1600" dirty="0">
-                <a:solidFill>
-                  <a:schemeClr val="bg1"/>
-                </a:solidFill>
-              </a:rPr>
-              <a:t>Read aloud every day</a:t>
-            </a:r>
-            <a:endParaRPr lang="en-US" sz="1600" dirty="0"/>
-          </a:p>
-          <a:p>
-            <a:pPr marL="177800" indent="-177800">
-              <a:spcAft>
-                <a:spcPts val="800"/>
-              </a:spcAft>
-              <a:buSzPct val="100000"/>
-              <a:buChar char="•"/>
-            </a:pPr>
-            <a:r>
-              <a:rPr lang="en-US" sz="1600" dirty="0">
-                <a:solidFill>
-                  <a:schemeClr val="bg1"/>
-                </a:solidFill>
-              </a:rPr>
-              <a:t>Always believe a child who tells you</a:t>
-            </a:r>
-            <a:endParaRPr lang="en-US" sz="1600" dirty="0"/>
-          </a:p>
-        </p:txBody>
-      </p:sp>
-      <p:sp>
-        <p:nvSpPr>
-          <p:cNvPr id="6" name="Menu button">
-            <a:hlinkClick r:id="rId4" action="ppaction://hlinksldjump" tooltip="Open the topic menu"/>
+        </p:spPr>
+        <p:txBody>
+          <a:bodyPr wrap="square" lIns="0" tIns="0" rIns="0" bIns="0" anchor="ctr"/>
+          <a:lstStyle/>
+          <a:p>
+            <a:pPr algn="ctr">
+              <a:buNone/>
+            </a:pPr>
+            <a:r>
+              <a:rPr lang="en-US" sz="1100" dirty="0">
+                <a:solidFill>
+                  <a:schemeClr val="tx1"/>
+                </a:solidFill>
+              </a:rPr>
+              <a:t>Tap the video to play. It streams online, so an internet connection is needed (youtu.be/GaX03lxP5CA).</a:t>
+            </a:r>
+          </a:p>
+        </p:txBody>
+      </p:sp>
+      <p:sp>
+        <p:nvSpPr>
+          <p:cNvPr id="4" name="Back button">
+            <a:hlinkClick r:id="rId3" action="ppaction://hlinksldjump" tooltip="Previous slide"/>
           </p:cNvPr>
           <p:cNvSpPr/>
           <p:nvPr/>
         </p:nvSpPr>
         <p:spPr>
           <a:xfrm>
-            <a:off x="548640" y="4160520"/>
-            <a:ext cx="1828800" cy="420624"/>
+            <a:off x="5989320" y="4636008"/>
+            <a:ext cx="1051560" cy="347472"/>
           </a:xfrm>
           <a:prstGeom prst="roundRect">
             <a:avLst>
@@ -7879,7 +7706,7 @@
             </a:avLst>
           </a:prstGeom>
           <a:solidFill>
-            <a:schemeClr val="accent3"/>
+            <a:schemeClr val="bg1"/>
           </a:solidFill>
           <a:ln/>
         </p:spPr>
@@ -7896,7 +7723,7 @@
                   <a:schemeClr val="tx1"/>
                 </a:solidFill>
               </a:rPr>
-              <a:t>Back to menu</a:t>
+              <a:t>‹ Back</a:t>
             </a:r>
             <a:endParaRPr lang="en-US" sz="1400" dirty="0"/>
           </a:p>
@@ -7904,16 +7731,16 @@
       </p:sp>
       <p:sp>
         <p:nvSpPr>
-          <p:cNvPr id="7" name="Retake button">
-            <a:hlinkClick r:id="rId5" action="ppaction://hlinksldjump" tooltip="Restart the quiz"/>
+          <p:cNvPr id="5" name="Next button">
+            <a:hlinkClick r:id="rId4" action="ppaction://hlinksldjump" tooltip="Next slide"/>
           </p:cNvPr>
           <p:cNvSpPr/>
           <p:nvPr/>
         </p:nvSpPr>
         <p:spPr>
           <a:xfrm>
-            <a:off x="2560320" y="4160520"/>
-            <a:ext cx="1645920" cy="420624"/>
+            <a:off x="7132320" y="4636008"/>
+            <a:ext cx="1554480" cy="347472"/>
           </a:xfrm>
           <a:prstGeom prst="roundRect">
             <a:avLst>
@@ -7921,7 +7748,7 @@
             </a:avLst>
           </a:prstGeom>
           <a:solidFill>
-            <a:schemeClr val="tx2"/>
+            <a:schemeClr val="tx1"/>
           </a:solidFill>
           <a:ln/>
         </p:spPr>
@@ -7938,7 +7765,7 @@
                   <a:schemeClr val="bg1"/>
                 </a:solidFill>
               </a:rPr>
-              <a:t>Retake quiz</a:t>
+              <a:t>Milk storage ›</a:t>
             </a:r>
             <a:endParaRPr lang="en-US" sz="1400" dirty="0"/>
           </a:p>
@@ -10855,6 +10682,48 @@
           </a:p>
         </p:txBody>
       </p:sp>
+      <p:sp>
+        <p:nvSpPr>
+          <p:cNvPr id="30" name="Watch video button">
+            <a:hlinkClick r:id="rId7" action="ppaction://hlinksldjump" tooltip="Watch video ›"/>
+          </p:cNvPr>
+          <p:cNvSpPr/>
+          <p:nvPr/>
+        </p:nvSpPr>
+        <p:spPr>
+          <a:xfrm>
+            <a:off x="3017520" y="1371600"/>
+            <a:ext cx="1371600" cy="329184"/>
+          </a:xfrm>
+          <a:prstGeom prst="roundRect">
+            <a:avLst>
+              <a:gd name="adj" fmla="val 50000"/>
+            </a:avLst>
+          </a:prstGeom>
+          <a:solidFill>
+            <a:schemeClr val="tx1"/>
+          </a:solidFill>
+          <a:ln/>
+        </p:spPr>
+        <p:txBody>
+          <a:bodyPr wrap="square" lIns="0" tIns="0" rIns="0" bIns="0" rtlCol="0" anchor="ctr"/>
+          <a:lstStyle/>
+          <a:p>
+            <a:pPr marL="0" indent="0" algn="ctr">
+              <a:buNone/>
+            </a:pPr>
+            <a:r>
+              <a:rPr lang="en-US" sz="1200" b="1" dirty="0">
+                <a:solidFill>
+                  <a:schemeClr val="bg1"/>
+                </a:solidFill>
+              </a:rPr>
+              <a:t>Watch video ›</a:t>
+            </a:r>
+            <a:endParaRPr lang="en-US" sz="1200" dirty="0"/>
+          </a:p>
+        </p:txBody>
+      </p:sp>
     </p:spTree>
   </p:cSld>
   <p:clrMapOvr>
@@ -10978,7 +10847,7 @@
         </p:nvGraphicFramePr>
         <p:xfrm>
           <a:off x="457200" y="1143000"/>
-          <a:ext cx="5394960" cy="914400"/>
+          <a:ext cx="5394960" cy="3200400"/>
         </p:xfrm>
         <a:graphic>
           <a:graphicData uri="http://schemas.openxmlformats.org/drawingml/2006/table">
@@ -14197,7 +14066,7 @@
 
 <file path=ppt/slides/slide9.xml><?xml version="1.0" encoding="utf-8"?>
 <p:sld xmlns:a="http://schemas.openxmlformats.org/drawingml/2006/main" xmlns:r="http://schemas.openxmlformats.org/officeDocument/2006/relationships" xmlns:p="http://schemas.openxmlformats.org/presentationml/2006/main">
-  <p:cSld name="Slide 9">
+  <p:cSld name="Slide 10">
     <p:spTree>
       <p:nvGrpSpPr>
         <p:cNvPr id="1" name=""/>
@@ -14212,24 +14081,44 @@
           <a:chExt cx="0" cy="0"/>
         </a:xfrm>
       </p:grpSpPr>
-      <p:sp>
-        <p:nvSpPr>
-          <p:cNvPr id="2" name="Text 0"/>
-          <p:cNvSpPr>
-            <a:spLocks noGrp="1"/>
-          </p:cNvSpPr>
-          <p:nvPr>
-            <p:ph type="title" idx="100" hasCustomPrompt="1"/>
-          </p:nvPr>
-        </p:nvSpPr>
-        <p:spPr>
-          <a:xfrm>
-            <a:off x="457200" y="274320"/>
-            <a:ext cx="6949440" cy="640080"/>
+      <p:pic>
+        <p:nvPicPr>
+          <p:cNvPr id="2" name="High five photo" descr="A father and his toddler high-five at sunset on the beach"/>
+          <p:cNvPicPr>
+            <a:picLocks noChangeAspect="1"/>
+          </p:cNvPicPr>
+          <p:nvPr/>
+        </p:nvPicPr>
+        <p:blipFill>
+          <a:blip r:embed="rId3"/>
+          <a:stretch>
+            <a:fillRect/>
+          </a:stretch>
+        </p:blipFill>
+        <p:spPr>
+          <a:xfrm>
+            <a:off x="4754880" y="0"/>
+            <a:ext cx="4389120" cy="5143500"/>
           </a:xfrm>
           <a:prstGeom prst="rect">
             <a:avLst/>
           </a:prstGeom>
+        </p:spPr>
+      </p:pic>
+      <p:sp>
+        <p:nvSpPr>
+          <p:cNvPr id="3" name="Eyebrow"/>
+          <p:cNvSpPr txBox="1"/>
+          <p:nvPr/>
+        </p:nvSpPr>
+        <p:spPr>
+          <a:xfrm>
+            <a:off x="548640" y="1097280"/>
+            <a:ext cx="3931920" cy="320040"/>
+          </a:xfrm>
+          <a:prstGeom prst="rect">
+            <a:avLst/>
+          </a:prstGeom>
           <a:noFill/>
           <a:ln/>
         </p:spPr>
@@ -14237,33 +14126,108 @@
           <a:bodyPr wrap="square" lIns="0" tIns="0" rIns="0" bIns="0" rtlCol="0" anchor="ctr"/>
           <a:lstStyle/>
           <a:p>
-            <a:pPr marL="0" indent="0" algn="l">
-              <a:buNone/>
-            </a:pPr>
-            <a:r>
-              <a:rPr lang="en-US" sz="3000" b="1" dirty="0">
-                <a:solidFill>
-                  <a:schemeClr val="tx1"/>
-                </a:solidFill>
-              </a:rPr>
-              <a:t>Teens: the HEEADSSS check-in</a:t>
-            </a:r>
-            <a:endParaRPr lang="en-US" sz="3000" dirty="0"/>
-          </a:p>
-        </p:txBody>
-      </p:sp>
-      <p:sp>
-        <p:nvSpPr>
-          <p:cNvPr id="3" name="Menu button">
-            <a:hlinkClick r:id="rId3" action="ppaction://hlinksldjump" tooltip="Back to the topic menu"/>
+            <a:pPr marL="0" indent="0">
+              <a:buNone/>
+            </a:pPr>
+            <a:r>
+              <a:rPr lang="en-US" sz="1400" b="1" kern="0" spc="400" dirty="0">
+                <a:solidFill>
+                  <a:schemeClr val="accent3"/>
+                </a:solidFill>
+              </a:rPr>
+              <a:t>QUICK QUIZ</a:t>
+            </a:r>
+            <a:endParaRPr lang="en-US" sz="1400" dirty="0"/>
+          </a:p>
+        </p:txBody>
+      </p:sp>
+      <p:sp>
+        <p:nvSpPr>
+          <p:cNvPr id="4" name="Quiz title"/>
+          <p:cNvSpPr txBox="1"/>
+          <p:nvPr/>
+        </p:nvSpPr>
+        <p:spPr>
+          <a:xfrm>
+            <a:off x="548640" y="1508760"/>
+            <a:ext cx="3931920" cy="1280160"/>
+          </a:xfrm>
+          <a:prstGeom prst="rect">
+            <a:avLst/>
+          </a:prstGeom>
+          <a:noFill/>
+          <a:ln/>
+        </p:spPr>
+        <p:txBody>
+          <a:bodyPr wrap="square" lIns="0" tIns="0" rIns="0" bIns="0" rtlCol="0" anchor="t"/>
+          <a:lstStyle/>
+          <a:p>
+            <a:pPr marL="0" indent="0">
+              <a:buNone/>
+            </a:pPr>
+            <a:r>
+              <a:rPr lang="en-US" sz="3600" b="1" dirty="0">
+                <a:solidFill>
+                  <a:schemeClr val="bg1"/>
+                </a:solidFill>
+                <a:latin typeface="+mj-lt" pitchFamily="34" charset="0"/>
+                <a:ea typeface="+mj-lt" pitchFamily="34" charset="-122"/>
+                <a:cs typeface="+mj-lt" pitchFamily="34" charset="-120"/>
+              </a:rPr>
+              <a:t>Test what you learned</a:t>
+            </a:r>
+            <a:endParaRPr lang="en-US" sz="3600" dirty="0"/>
+          </a:p>
+        </p:txBody>
+      </p:sp>
+      <p:sp>
+        <p:nvSpPr>
+          <p:cNvPr id="5" name="Quiz instructions"/>
+          <p:cNvSpPr txBox="1"/>
+          <p:nvPr/>
+        </p:nvSpPr>
+        <p:spPr>
+          <a:xfrm>
+            <a:off x="548640" y="2926080"/>
+            <a:ext cx="3840480" cy="822960"/>
+          </a:xfrm>
+          <a:prstGeom prst="rect">
+            <a:avLst/>
+          </a:prstGeom>
+          <a:noFill/>
+          <a:ln/>
+        </p:spPr>
+        <p:txBody>
+          <a:bodyPr wrap="square" lIns="0" tIns="0" rIns="0" bIns="0" rtlCol="0" anchor="t"/>
+          <a:lstStyle/>
+          <a:p>
+            <a:pPr marL="0" indent="0">
+              <a:buNone/>
+            </a:pPr>
+            <a:r>
+              <a:rPr lang="en-US" sz="1600" dirty="0">
+                <a:solidFill>
+                  <a:schemeClr val="bg1"/>
+                </a:solidFill>
+              </a:rPr>
+              <a:t>4 questions. Tap an answer to see if you got it right. Wrong answer? You can try again.</a:t>
+            </a:r>
+            <a:endParaRPr lang="en-US" sz="1600" dirty="0"/>
+          </a:p>
+        </p:txBody>
+      </p:sp>
+      <p:sp>
+        <p:nvSpPr>
+          <p:cNvPr id="6" name="Start quiz">
+            <a:hlinkClick r:id="rId4" action="ppaction://hlinksldjump" tooltip="Go to question 1"/>
           </p:cNvPr>
           <p:cNvSpPr/>
           <p:nvPr/>
         </p:nvSpPr>
         <p:spPr>
           <a:xfrm>
-            <a:off x="7635240" y="365760"/>
-            <a:ext cx="1051560" cy="365760"/>
+            <a:off x="548640" y="3977640"/>
+            <a:ext cx="1645920" cy="420624"/>
           </a:xfrm>
           <a:prstGeom prst="roundRect">
             <a:avLst>
@@ -14271,7 +14235,7 @@
             </a:avLst>
           </a:prstGeom>
           <a:solidFill>
-            <a:schemeClr val="tx1"/>
+            <a:schemeClr val="accent3"/>
           </a:solidFill>
           <a:ln/>
         </p:spPr>
@@ -14285,1102 +14249,27 @@
             <a:r>
               <a:rPr lang="en-US" sz="1400" b="1" dirty="0">
                 <a:solidFill>
-                  <a:schemeClr val="bg1"/>
-                </a:solidFill>
-              </a:rPr>
-              <a:t>Menu</a:t>
+                  <a:schemeClr val="tx1"/>
+                </a:solidFill>
+              </a:rPr>
+              <a:t>Start quiz</a:t>
             </a:r>
             <a:endParaRPr lang="en-US" sz="1400" dirty="0"/>
           </a:p>
         </p:txBody>
       </p:sp>
-      <p:pic>
-        <p:nvPicPr>
-          <p:cNvPr id="4" name="Family jumping photo" descr="Silhouette of a family of three jumping together in a field at sunset"/>
-          <p:cNvPicPr>
-            <a:picLocks noChangeAspect="1"/>
-          </p:cNvPicPr>
-          <p:nvPr/>
-        </p:nvPicPr>
-        <p:blipFill>
-          <a:blip r:embed="rId4"/>
-          <a:stretch>
-            <a:fillRect/>
-          </a:stretch>
-        </p:blipFill>
-        <p:spPr>
-          <a:xfrm>
-            <a:off x="457200" y="1143000"/>
-            <a:ext cx="2926080" cy="2194560"/>
-          </a:xfrm>
-          <a:prstGeom prst="rect">
-            <a:avLst/>
-          </a:prstGeom>
-        </p:spPr>
-      </p:pic>
-      <p:sp>
-        <p:nvSpPr>
-          <p:cNvPr id="5" name="Teen counseling card"/>
-          <p:cNvSpPr/>
-          <p:nvPr/>
-        </p:nvSpPr>
-        <p:spPr>
-          <a:xfrm>
-            <a:off x="457200" y="3474720"/>
-            <a:ext cx="2926080" cy="1097280"/>
-          </a:xfrm>
-          <a:prstGeom prst="roundRect">
-            <a:avLst>
-              <a:gd name="adj" fmla="val 10000"/>
-            </a:avLst>
-          </a:prstGeom>
-          <a:solidFill>
-            <a:schemeClr val="bg1"/>
-          </a:solidFill>
-          <a:ln w="12700">
-            <a:solidFill>
-              <a:schemeClr val="bg1"/>
-            </a:solidFill>
-            <a:prstDash val="solid"/>
-          </a:ln>
-          <a:effectLst>
-            <a:outerShdw blurRad="101600" dist="25400" dir="5400000" algn="bl" rotWithShape="0">
-              <a:srgbClr val="1B2540">
-                <a:alpha val="14000"/>
-              </a:srgbClr>
-            </a:outerShdw>
-          </a:effectLst>
-        </p:spPr>
-      </p:sp>
-      <p:sp>
-        <p:nvSpPr>
-          <p:cNvPr id="6" name="Teen counseling text"/>
-          <p:cNvSpPr txBox="1"/>
-          <p:nvPr/>
-        </p:nvSpPr>
-        <p:spPr>
-          <a:xfrm>
-            <a:off x="621792" y="3547872"/>
-            <a:ext cx="2615184" cy="960120"/>
-          </a:xfrm>
-          <a:prstGeom prst="rect">
-            <a:avLst/>
-          </a:prstGeom>
-          <a:noFill/>
-          <a:ln/>
-        </p:spPr>
-        <p:txBody>
-          <a:bodyPr wrap="square" lIns="0" tIns="0" rIns="0" bIns="0" rtlCol="0" anchor="ctr"/>
-          <a:lstStyle/>
-          <a:p>
-            <a:pPr marL="0" indent="0">
-              <a:buNone/>
-            </a:pPr>
-            <a:r>
-              <a:rPr lang="en-US" sz="1400" dirty="0">
-                <a:solidFill>
-                  <a:schemeClr val="tx2"/>
-                </a:solidFill>
-              </a:rPr>
-              <a:t>Use it at every annual visit, then counsel on healthy lifestyle, sexual behavior and STI risk, and injury prevention.</a:t>
-            </a:r>
-            <a:endParaRPr lang="en-US" sz="1400" dirty="0"/>
-          </a:p>
-        </p:txBody>
-      </p:sp>
-      <p:sp>
-        <p:nvSpPr>
-          <p:cNvPr id="7" name="Tile Home"/>
-          <p:cNvSpPr/>
-          <p:nvPr/>
-        </p:nvSpPr>
-        <p:spPr>
-          <a:xfrm>
-            <a:off x="3611880" y="1143000"/>
-            <a:ext cx="1600200" cy="1051560"/>
-          </a:xfrm>
-          <a:prstGeom prst="roundRect">
-            <a:avLst>
-              <a:gd name="adj" fmla="val 8696"/>
-            </a:avLst>
-          </a:prstGeom>
-          <a:solidFill>
-            <a:schemeClr val="bg1"/>
-          </a:solidFill>
-          <a:ln w="12700">
-            <a:solidFill>
-              <a:schemeClr val="bg1"/>
-            </a:solidFill>
-            <a:prstDash val="solid"/>
-          </a:ln>
-          <a:effectLst>
-            <a:outerShdw blurRad="101600" dist="25400" dir="5400000" algn="bl" rotWithShape="0">
-              <a:srgbClr val="1B2540">
-                <a:alpha val="14000"/>
-              </a:srgbClr>
-            </a:outerShdw>
-          </a:effectLst>
-        </p:spPr>
-      </p:sp>
-      <p:sp>
-        <p:nvSpPr>
-          <p:cNvPr id="8" name="Tile letter Home"/>
-          <p:cNvSpPr txBox="1"/>
-          <p:nvPr/>
-        </p:nvSpPr>
-        <p:spPr>
-          <a:xfrm>
-            <a:off x="3721608" y="1188720"/>
-            <a:ext cx="1371600" cy="457200"/>
-          </a:xfrm>
-          <a:prstGeom prst="rect">
-            <a:avLst/>
-          </a:prstGeom>
-          <a:noFill/>
-          <a:ln/>
-        </p:spPr>
-        <p:txBody>
-          <a:bodyPr wrap="square" lIns="0" tIns="0" rIns="0" bIns="0" rtlCol="0" anchor="ctr"/>
-          <a:lstStyle/>
-          <a:p>
-            <a:pPr marL="0" indent="0">
-              <a:buNone/>
-            </a:pPr>
-            <a:r>
-              <a:rPr lang="en-US" sz="2600" b="1" dirty="0">
-                <a:solidFill>
-                  <a:schemeClr val="accent1"/>
-                </a:solidFill>
-                <a:latin typeface="+mj-lt" pitchFamily="34" charset="0"/>
-                <a:ea typeface="+mj-lt" pitchFamily="34" charset="-122"/>
-                <a:cs typeface="+mj-lt" pitchFamily="34" charset="-120"/>
-              </a:rPr>
-              <a:t>H</a:t>
-            </a:r>
-            <a:endParaRPr lang="en-US" sz="2600" dirty="0"/>
-          </a:p>
-        </p:txBody>
-      </p:sp>
-      <p:sp>
-        <p:nvSpPr>
-          <p:cNvPr id="9" name="Tile word Home"/>
-          <p:cNvSpPr txBox="1"/>
-          <p:nvPr/>
-        </p:nvSpPr>
-        <p:spPr>
-          <a:xfrm>
-            <a:off x="3721608" y="1645920"/>
-            <a:ext cx="1417320" cy="502920"/>
-          </a:xfrm>
-          <a:prstGeom prst="rect">
-            <a:avLst/>
-          </a:prstGeom>
-          <a:noFill/>
-          <a:ln/>
-        </p:spPr>
-        <p:txBody>
-          <a:bodyPr wrap="square" lIns="0" tIns="0" rIns="0" bIns="0" rtlCol="0" anchor="t"/>
-          <a:lstStyle/>
-          <a:p>
-            <a:pPr marL="0" indent="0">
-              <a:buNone/>
-            </a:pPr>
-            <a:r>
-              <a:rPr lang="en-US" sz="1400" dirty="0">
-                <a:solidFill>
-                  <a:schemeClr val="tx2"/>
-                </a:solidFill>
-              </a:rPr>
-              <a:t>Home</a:t>
-            </a:r>
-            <a:endParaRPr lang="en-US" sz="1400" dirty="0"/>
-          </a:p>
-        </p:txBody>
-      </p:sp>
-      <p:sp>
-        <p:nvSpPr>
-          <p:cNvPr id="10" name="Tile Education and employment"/>
-          <p:cNvSpPr/>
-          <p:nvPr/>
-        </p:nvSpPr>
-        <p:spPr>
-          <a:xfrm>
-            <a:off x="5330952" y="1143000"/>
-            <a:ext cx="1600200" cy="1051560"/>
-          </a:xfrm>
-          <a:prstGeom prst="roundRect">
-            <a:avLst>
-              <a:gd name="adj" fmla="val 8696"/>
-            </a:avLst>
-          </a:prstGeom>
-          <a:solidFill>
-            <a:schemeClr val="bg1"/>
-          </a:solidFill>
-          <a:ln w="12700">
-            <a:solidFill>
-              <a:schemeClr val="bg1"/>
-            </a:solidFill>
-            <a:prstDash val="solid"/>
-          </a:ln>
-          <a:effectLst>
-            <a:outerShdw blurRad="101600" dist="25400" dir="5400000" algn="bl" rotWithShape="0">
-              <a:srgbClr val="1B2540">
-                <a:alpha val="14000"/>
-              </a:srgbClr>
-            </a:outerShdw>
-          </a:effectLst>
-        </p:spPr>
-      </p:sp>
-      <p:sp>
-        <p:nvSpPr>
-          <p:cNvPr id="11" name="Tile letter Education and employment"/>
-          <p:cNvSpPr txBox="1"/>
-          <p:nvPr/>
-        </p:nvSpPr>
-        <p:spPr>
-          <a:xfrm>
-            <a:off x="5440680" y="1188720"/>
-            <a:ext cx="1371600" cy="457200"/>
-          </a:xfrm>
-          <a:prstGeom prst="rect">
-            <a:avLst/>
-          </a:prstGeom>
-          <a:noFill/>
-          <a:ln/>
-        </p:spPr>
-        <p:txBody>
-          <a:bodyPr wrap="square" lIns="0" tIns="0" rIns="0" bIns="0" rtlCol="0" anchor="ctr"/>
-          <a:lstStyle/>
-          <a:p>
-            <a:pPr marL="0" indent="0">
-              <a:buNone/>
-            </a:pPr>
-            <a:r>
-              <a:rPr lang="en-US" sz="2600" b="1" dirty="0">
-                <a:solidFill>
-                  <a:schemeClr val="accent2"/>
-                </a:solidFill>
-                <a:latin typeface="+mj-lt" pitchFamily="34" charset="0"/>
-                <a:ea typeface="+mj-lt" pitchFamily="34" charset="-122"/>
-                <a:cs typeface="+mj-lt" pitchFamily="34" charset="-120"/>
-              </a:rPr>
-              <a:t>E</a:t>
-            </a:r>
-            <a:endParaRPr lang="en-US" sz="2600" dirty="0"/>
-          </a:p>
-        </p:txBody>
-      </p:sp>
-      <p:sp>
-        <p:nvSpPr>
-          <p:cNvPr id="12" name="Tile word Education and employment"/>
-          <p:cNvSpPr txBox="1"/>
-          <p:nvPr/>
-        </p:nvSpPr>
-        <p:spPr>
-          <a:xfrm>
-            <a:off x="5440680" y="1645920"/>
-            <a:ext cx="1417320" cy="502920"/>
-          </a:xfrm>
-          <a:prstGeom prst="rect">
-            <a:avLst/>
-          </a:prstGeom>
-          <a:noFill/>
-          <a:ln/>
-        </p:spPr>
-        <p:txBody>
-          <a:bodyPr wrap="square" lIns="0" tIns="0" rIns="0" bIns="0" rtlCol="0" anchor="t"/>
-          <a:lstStyle/>
-          <a:p>
-            <a:pPr marL="0" indent="0">
-              <a:buNone/>
-            </a:pPr>
-            <a:r>
-              <a:rPr lang="en-US" sz="1400" dirty="0">
-                <a:solidFill>
-                  <a:schemeClr val="tx2"/>
-                </a:solidFill>
-              </a:rPr>
-              <a:t>Education and employment</a:t>
-            </a:r>
-            <a:endParaRPr lang="en-US" sz="1400" dirty="0"/>
-          </a:p>
-        </p:txBody>
-      </p:sp>
-      <p:sp>
-        <p:nvSpPr>
-          <p:cNvPr id="13" name="Tile Eating"/>
-          <p:cNvSpPr/>
-          <p:nvPr/>
-        </p:nvSpPr>
-        <p:spPr>
-          <a:xfrm>
-            <a:off x="7050024" y="1143000"/>
-            <a:ext cx="1600200" cy="1051560"/>
-          </a:xfrm>
-          <a:prstGeom prst="roundRect">
-            <a:avLst>
-              <a:gd name="adj" fmla="val 8696"/>
-            </a:avLst>
-          </a:prstGeom>
-          <a:solidFill>
-            <a:schemeClr val="bg1"/>
-          </a:solidFill>
-          <a:ln w="12700">
-            <a:solidFill>
-              <a:schemeClr val="bg1"/>
-            </a:solidFill>
-            <a:prstDash val="solid"/>
-          </a:ln>
-          <a:effectLst>
-            <a:outerShdw blurRad="101600" dist="25400" dir="5400000" algn="bl" rotWithShape="0">
-              <a:srgbClr val="1B2540">
-                <a:alpha val="14000"/>
-              </a:srgbClr>
-            </a:outerShdw>
-          </a:effectLst>
-        </p:spPr>
-      </p:sp>
-      <p:sp>
-        <p:nvSpPr>
-          <p:cNvPr id="14" name="Tile letter Eating"/>
-          <p:cNvSpPr txBox="1"/>
-          <p:nvPr/>
-        </p:nvSpPr>
-        <p:spPr>
-          <a:xfrm>
-            <a:off x="7159752" y="1188720"/>
-            <a:ext cx="1371600" cy="457200"/>
-          </a:xfrm>
-          <a:prstGeom prst="rect">
-            <a:avLst/>
-          </a:prstGeom>
-          <a:noFill/>
-          <a:ln/>
-        </p:spPr>
-        <p:txBody>
-          <a:bodyPr wrap="square" lIns="0" tIns="0" rIns="0" bIns="0" rtlCol="0" anchor="ctr"/>
-          <a:lstStyle/>
-          <a:p>
-            <a:pPr marL="0" indent="0">
-              <a:buNone/>
-            </a:pPr>
-            <a:r>
-              <a:rPr lang="en-US" sz="2600" b="1" dirty="0">
-                <a:solidFill>
-                  <a:schemeClr val="accent4"/>
-                </a:solidFill>
-                <a:latin typeface="+mj-lt" pitchFamily="34" charset="0"/>
-                <a:ea typeface="+mj-lt" pitchFamily="34" charset="-122"/>
-                <a:cs typeface="+mj-lt" pitchFamily="34" charset="-120"/>
-              </a:rPr>
-              <a:t>E</a:t>
-            </a:r>
-            <a:endParaRPr lang="en-US" sz="2600" dirty="0"/>
-          </a:p>
-        </p:txBody>
-      </p:sp>
-      <p:sp>
-        <p:nvSpPr>
-          <p:cNvPr id="15" name="Tile word Eating"/>
-          <p:cNvSpPr txBox="1"/>
-          <p:nvPr/>
-        </p:nvSpPr>
-        <p:spPr>
-          <a:xfrm>
-            <a:off x="7159752" y="1645920"/>
-            <a:ext cx="1417320" cy="502920"/>
-          </a:xfrm>
-          <a:prstGeom prst="rect">
-            <a:avLst/>
-          </a:prstGeom>
-          <a:noFill/>
-          <a:ln/>
-        </p:spPr>
-        <p:txBody>
-          <a:bodyPr wrap="square" lIns="0" tIns="0" rIns="0" bIns="0" rtlCol="0" anchor="t"/>
-          <a:lstStyle/>
-          <a:p>
-            <a:pPr marL="0" indent="0">
-              <a:buNone/>
-            </a:pPr>
-            <a:r>
-              <a:rPr lang="en-US" sz="1400" dirty="0">
-                <a:solidFill>
-                  <a:schemeClr val="tx2"/>
-                </a:solidFill>
-              </a:rPr>
-              <a:t>Eating</a:t>
-            </a:r>
-            <a:endParaRPr lang="en-US" sz="1400" dirty="0"/>
-          </a:p>
-        </p:txBody>
-      </p:sp>
-      <p:sp>
-        <p:nvSpPr>
-          <p:cNvPr id="16" name="Tile Activities, media"/>
-          <p:cNvSpPr/>
-          <p:nvPr/>
-        </p:nvSpPr>
-        <p:spPr>
-          <a:xfrm>
-            <a:off x="3611880" y="2304288"/>
-            <a:ext cx="1600200" cy="1051560"/>
-          </a:xfrm>
-          <a:prstGeom prst="roundRect">
-            <a:avLst>
-              <a:gd name="adj" fmla="val 8696"/>
-            </a:avLst>
-          </a:prstGeom>
-          <a:solidFill>
-            <a:schemeClr val="bg1"/>
-          </a:solidFill>
-          <a:ln w="12700">
-            <a:solidFill>
-              <a:schemeClr val="bg1"/>
-            </a:solidFill>
-            <a:prstDash val="solid"/>
-          </a:ln>
-          <a:effectLst>
-            <a:outerShdw blurRad="101600" dist="25400" dir="5400000" algn="bl" rotWithShape="0">
-              <a:srgbClr val="1B2540">
-                <a:alpha val="14000"/>
-              </a:srgbClr>
-            </a:outerShdw>
-          </a:effectLst>
-        </p:spPr>
-      </p:sp>
-      <p:sp>
-        <p:nvSpPr>
-          <p:cNvPr id="17" name="Tile letter Activities, media"/>
-          <p:cNvSpPr txBox="1"/>
-          <p:nvPr/>
-        </p:nvSpPr>
-        <p:spPr>
-          <a:xfrm>
-            <a:off x="3721608" y="2350008"/>
-            <a:ext cx="1371600" cy="457200"/>
-          </a:xfrm>
-          <a:prstGeom prst="rect">
-            <a:avLst/>
-          </a:prstGeom>
-          <a:noFill/>
-          <a:ln/>
-        </p:spPr>
-        <p:txBody>
-          <a:bodyPr wrap="square" lIns="0" tIns="0" rIns="0" bIns="0" rtlCol="0" anchor="ctr"/>
-          <a:lstStyle/>
-          <a:p>
-            <a:pPr marL="0" indent="0">
-              <a:buNone/>
-            </a:pPr>
-            <a:r>
-              <a:rPr lang="en-US" sz="2600" b="1" dirty="0">
-                <a:solidFill>
-                  <a:schemeClr val="accent5"/>
-                </a:solidFill>
-                <a:latin typeface="+mj-lt" pitchFamily="34" charset="0"/>
-                <a:ea typeface="+mj-lt" pitchFamily="34" charset="-122"/>
-                <a:cs typeface="+mj-lt" pitchFamily="34" charset="-120"/>
-              </a:rPr>
-              <a:t>A</a:t>
-            </a:r>
-            <a:endParaRPr lang="en-US" sz="2600" dirty="0"/>
-          </a:p>
-        </p:txBody>
-      </p:sp>
-      <p:sp>
-        <p:nvSpPr>
-          <p:cNvPr id="18" name="Tile word Activities, media"/>
-          <p:cNvSpPr txBox="1"/>
-          <p:nvPr/>
-        </p:nvSpPr>
-        <p:spPr>
-          <a:xfrm>
-            <a:off x="3721608" y="2807208"/>
-            <a:ext cx="1417320" cy="502920"/>
-          </a:xfrm>
-          <a:prstGeom prst="rect">
-            <a:avLst/>
-          </a:prstGeom>
-          <a:noFill/>
-          <a:ln/>
-        </p:spPr>
-        <p:txBody>
-          <a:bodyPr wrap="square" lIns="0" tIns="0" rIns="0" bIns="0" rtlCol="0" anchor="t"/>
-          <a:lstStyle/>
-          <a:p>
-            <a:pPr marL="0" indent="0">
-              <a:buNone/>
-            </a:pPr>
-            <a:r>
-              <a:rPr lang="en-US" sz="1400" dirty="0">
-                <a:solidFill>
-                  <a:schemeClr val="tx2"/>
-                </a:solidFill>
-              </a:rPr>
-              <a:t>Activities, media</a:t>
-            </a:r>
-            <a:endParaRPr lang="en-US" sz="1400" dirty="0"/>
-          </a:p>
-        </p:txBody>
-      </p:sp>
-      <p:sp>
-        <p:nvSpPr>
-          <p:cNvPr id="19" name="Tile Drugs, alcohol, tobacco"/>
-          <p:cNvSpPr/>
-          <p:nvPr/>
-        </p:nvSpPr>
-        <p:spPr>
-          <a:xfrm>
-            <a:off x="5330952" y="2304288"/>
-            <a:ext cx="1600200" cy="1051560"/>
-          </a:xfrm>
-          <a:prstGeom prst="roundRect">
-            <a:avLst>
-              <a:gd name="adj" fmla="val 8696"/>
-            </a:avLst>
-          </a:prstGeom>
-          <a:solidFill>
-            <a:schemeClr val="bg1"/>
-          </a:solidFill>
-          <a:ln w="12700">
-            <a:solidFill>
-              <a:schemeClr val="bg1"/>
-            </a:solidFill>
-            <a:prstDash val="solid"/>
-          </a:ln>
-          <a:effectLst>
-            <a:outerShdw blurRad="101600" dist="25400" dir="5400000" algn="bl" rotWithShape="0">
-              <a:srgbClr val="1B2540">
-                <a:alpha val="14000"/>
-              </a:srgbClr>
-            </a:outerShdw>
-          </a:effectLst>
-        </p:spPr>
-      </p:sp>
-      <p:sp>
-        <p:nvSpPr>
-          <p:cNvPr id="20" name="Tile letter Drugs, alcohol, tobacco"/>
-          <p:cNvSpPr txBox="1"/>
-          <p:nvPr/>
-        </p:nvSpPr>
-        <p:spPr>
-          <a:xfrm>
-            <a:off x="5440680" y="2350008"/>
-            <a:ext cx="1371600" cy="457200"/>
-          </a:xfrm>
-          <a:prstGeom prst="rect">
-            <a:avLst/>
-          </a:prstGeom>
-          <a:noFill/>
-          <a:ln/>
-        </p:spPr>
-        <p:txBody>
-          <a:bodyPr wrap="square" lIns="0" tIns="0" rIns="0" bIns="0" rtlCol="0" anchor="ctr"/>
-          <a:lstStyle/>
-          <a:p>
-            <a:pPr marL="0" indent="0">
-              <a:buNone/>
-            </a:pPr>
-            <a:r>
-              <a:rPr lang="en-US" sz="2600" b="1" dirty="0">
-                <a:solidFill>
-                  <a:schemeClr val="accent6"/>
-                </a:solidFill>
-                <a:latin typeface="+mj-lt" pitchFamily="34" charset="0"/>
-                <a:ea typeface="+mj-lt" pitchFamily="34" charset="-122"/>
-                <a:cs typeface="+mj-lt" pitchFamily="34" charset="-120"/>
-              </a:rPr>
-              <a:t>D</a:t>
-            </a:r>
-            <a:endParaRPr lang="en-US" sz="2600" dirty="0"/>
-          </a:p>
-        </p:txBody>
-      </p:sp>
-      <p:sp>
-        <p:nvSpPr>
-          <p:cNvPr id="21" name="Tile word Drugs, alcohol, tobacco"/>
-          <p:cNvSpPr txBox="1"/>
-          <p:nvPr/>
-        </p:nvSpPr>
-        <p:spPr>
-          <a:xfrm>
-            <a:off x="5440680" y="2807208"/>
-            <a:ext cx="1417320" cy="502920"/>
-          </a:xfrm>
-          <a:prstGeom prst="rect">
-            <a:avLst/>
-          </a:prstGeom>
-          <a:noFill/>
-          <a:ln/>
-        </p:spPr>
-        <p:txBody>
-          <a:bodyPr wrap="square" lIns="0" tIns="0" rIns="0" bIns="0" rtlCol="0" anchor="t"/>
-          <a:lstStyle/>
-          <a:p>
-            <a:pPr marL="0" indent="0">
-              <a:buNone/>
-            </a:pPr>
-            <a:r>
-              <a:rPr lang="en-US" sz="1400" dirty="0">
-                <a:solidFill>
-                  <a:schemeClr val="tx2"/>
-                </a:solidFill>
-              </a:rPr>
-              <a:t>Drugs, alcohol, tobacco</a:t>
-            </a:r>
-            <a:endParaRPr lang="en-US" sz="1400" dirty="0"/>
-          </a:p>
-        </p:txBody>
-      </p:sp>
-      <p:sp>
-        <p:nvSpPr>
-          <p:cNvPr id="22" name="Tile Sexuality"/>
-          <p:cNvSpPr/>
-          <p:nvPr/>
-        </p:nvSpPr>
-        <p:spPr>
-          <a:xfrm>
-            <a:off x="7050024" y="2304288"/>
-            <a:ext cx="1600200" cy="1051560"/>
-          </a:xfrm>
-          <a:prstGeom prst="roundRect">
-            <a:avLst>
-              <a:gd name="adj" fmla="val 8696"/>
-            </a:avLst>
-          </a:prstGeom>
-          <a:solidFill>
-            <a:schemeClr val="bg1"/>
-          </a:solidFill>
-          <a:ln w="12700">
-            <a:solidFill>
-              <a:schemeClr val="bg1"/>
-            </a:solidFill>
-            <a:prstDash val="solid"/>
-          </a:ln>
-          <a:effectLst>
-            <a:outerShdw blurRad="101600" dist="25400" dir="5400000" algn="bl" rotWithShape="0">
-              <a:srgbClr val="1B2540">
-                <a:alpha val="14000"/>
-              </a:srgbClr>
-            </a:outerShdw>
-          </a:effectLst>
-        </p:spPr>
-      </p:sp>
-      <p:sp>
-        <p:nvSpPr>
-          <p:cNvPr id="23" name="Tile letter Sexuality"/>
-          <p:cNvSpPr txBox="1"/>
-          <p:nvPr/>
-        </p:nvSpPr>
-        <p:spPr>
-          <a:xfrm>
-            <a:off x="7159752" y="2350008"/>
-            <a:ext cx="1371600" cy="457200"/>
-          </a:xfrm>
-          <a:prstGeom prst="rect">
-            <a:avLst/>
-          </a:prstGeom>
-          <a:noFill/>
-          <a:ln/>
-        </p:spPr>
-        <p:txBody>
-          <a:bodyPr wrap="square" lIns="0" tIns="0" rIns="0" bIns="0" rtlCol="0" anchor="ctr"/>
-          <a:lstStyle/>
-          <a:p>
-            <a:pPr marL="0" indent="0">
-              <a:buNone/>
-            </a:pPr>
-            <a:r>
-              <a:rPr lang="en-US" sz="2600" b="1" dirty="0">
-                <a:solidFill>
-                  <a:schemeClr val="accent1"/>
-                </a:solidFill>
-                <a:latin typeface="+mj-lt" pitchFamily="34" charset="0"/>
-                <a:ea typeface="+mj-lt" pitchFamily="34" charset="-122"/>
-                <a:cs typeface="+mj-lt" pitchFamily="34" charset="-120"/>
-              </a:rPr>
-              <a:t>S</a:t>
-            </a:r>
-            <a:endParaRPr lang="en-US" sz="2600" dirty="0"/>
-          </a:p>
-        </p:txBody>
-      </p:sp>
-      <p:sp>
-        <p:nvSpPr>
-          <p:cNvPr id="24" name="Tile word Sexuality"/>
-          <p:cNvSpPr txBox="1"/>
-          <p:nvPr/>
-        </p:nvSpPr>
-        <p:spPr>
-          <a:xfrm>
-            <a:off x="7159752" y="2807208"/>
-            <a:ext cx="1417320" cy="502920"/>
-          </a:xfrm>
-          <a:prstGeom prst="rect">
-            <a:avLst/>
-          </a:prstGeom>
-          <a:noFill/>
-          <a:ln/>
-        </p:spPr>
-        <p:txBody>
-          <a:bodyPr wrap="square" lIns="0" tIns="0" rIns="0" bIns="0" rtlCol="0" anchor="t"/>
-          <a:lstStyle/>
-          <a:p>
-            <a:pPr marL="0" indent="0">
-              <a:buNone/>
-            </a:pPr>
-            <a:r>
-              <a:rPr lang="en-US" sz="1400" dirty="0">
-                <a:solidFill>
-                  <a:schemeClr val="tx2"/>
-                </a:solidFill>
-              </a:rPr>
-              <a:t>Sexuality</a:t>
-            </a:r>
-            <a:endParaRPr lang="en-US" sz="1400" dirty="0"/>
-          </a:p>
-        </p:txBody>
-      </p:sp>
-      <p:sp>
-        <p:nvSpPr>
-          <p:cNvPr id="25" name="Tile Suicidality, depression"/>
-          <p:cNvSpPr/>
-          <p:nvPr/>
-        </p:nvSpPr>
-        <p:spPr>
-          <a:xfrm>
-            <a:off x="3611880" y="3465576"/>
-            <a:ext cx="1600200" cy="1051560"/>
-          </a:xfrm>
-          <a:prstGeom prst="roundRect">
-            <a:avLst>
-              <a:gd name="adj" fmla="val 8696"/>
-            </a:avLst>
-          </a:prstGeom>
-          <a:solidFill>
-            <a:schemeClr val="bg1"/>
-          </a:solidFill>
-          <a:ln w="12700">
-            <a:solidFill>
-              <a:schemeClr val="bg1"/>
-            </a:solidFill>
-            <a:prstDash val="solid"/>
-          </a:ln>
-          <a:effectLst>
-            <a:outerShdw blurRad="101600" dist="25400" dir="5400000" algn="bl" rotWithShape="0">
-              <a:srgbClr val="1B2540">
-                <a:alpha val="14000"/>
-              </a:srgbClr>
-            </a:outerShdw>
-          </a:effectLst>
-        </p:spPr>
-      </p:sp>
-      <p:sp>
-        <p:nvSpPr>
-          <p:cNvPr id="26" name="Tile letter Suicidality, depression"/>
-          <p:cNvSpPr txBox="1"/>
-          <p:nvPr/>
-        </p:nvSpPr>
-        <p:spPr>
-          <a:xfrm>
-            <a:off x="3721608" y="3511296"/>
-            <a:ext cx="1371600" cy="457200"/>
-          </a:xfrm>
-          <a:prstGeom prst="rect">
-            <a:avLst/>
-          </a:prstGeom>
-          <a:noFill/>
-          <a:ln/>
-        </p:spPr>
-        <p:txBody>
-          <a:bodyPr wrap="square" lIns="0" tIns="0" rIns="0" bIns="0" rtlCol="0" anchor="ctr"/>
-          <a:lstStyle/>
-          <a:p>
-            <a:pPr marL="0" indent="0">
-              <a:buNone/>
-            </a:pPr>
-            <a:r>
-              <a:rPr lang="en-US" sz="2600" b="1" dirty="0">
-                <a:solidFill>
-                  <a:schemeClr val="accent2"/>
-                </a:solidFill>
-                <a:latin typeface="+mj-lt" pitchFamily="34" charset="0"/>
-                <a:ea typeface="+mj-lt" pitchFamily="34" charset="-122"/>
-                <a:cs typeface="+mj-lt" pitchFamily="34" charset="-120"/>
-              </a:rPr>
-              <a:t>S</a:t>
-            </a:r>
-            <a:endParaRPr lang="en-US" sz="2600" dirty="0"/>
-          </a:p>
-        </p:txBody>
-      </p:sp>
-      <p:sp>
-        <p:nvSpPr>
-          <p:cNvPr id="27" name="Tile word Suicidality, depression"/>
-          <p:cNvSpPr txBox="1"/>
-          <p:nvPr/>
-        </p:nvSpPr>
-        <p:spPr>
-          <a:xfrm>
-            <a:off x="3721608" y="3968496"/>
-            <a:ext cx="1417320" cy="502920"/>
-          </a:xfrm>
-          <a:prstGeom prst="rect">
-            <a:avLst/>
-          </a:prstGeom>
-          <a:noFill/>
-          <a:ln/>
-        </p:spPr>
-        <p:txBody>
-          <a:bodyPr wrap="square" lIns="0" tIns="0" rIns="0" bIns="0" rtlCol="0" anchor="t"/>
-          <a:lstStyle/>
-          <a:p>
-            <a:pPr marL="0" indent="0">
-              <a:buNone/>
-            </a:pPr>
-            <a:r>
-              <a:rPr lang="en-US" sz="1400" dirty="0">
-                <a:solidFill>
-                  <a:schemeClr val="tx2"/>
-                </a:solidFill>
-              </a:rPr>
-              <a:t>Suicidality, depression</a:t>
-            </a:r>
-            <a:endParaRPr lang="en-US" sz="1400" dirty="0"/>
-          </a:p>
-        </p:txBody>
-      </p:sp>
-      <p:sp>
-        <p:nvSpPr>
-          <p:cNvPr id="28" name="Tile Safety"/>
-          <p:cNvSpPr/>
-          <p:nvPr/>
-        </p:nvSpPr>
-        <p:spPr>
-          <a:xfrm>
-            <a:off x="5330952" y="3465576"/>
-            <a:ext cx="1600200" cy="1051560"/>
-          </a:xfrm>
-          <a:prstGeom prst="roundRect">
-            <a:avLst>
-              <a:gd name="adj" fmla="val 8696"/>
-            </a:avLst>
-          </a:prstGeom>
-          <a:solidFill>
-            <a:schemeClr val="bg1"/>
-          </a:solidFill>
-          <a:ln w="12700">
-            <a:solidFill>
-              <a:schemeClr val="bg1"/>
-            </a:solidFill>
-            <a:prstDash val="solid"/>
-          </a:ln>
-          <a:effectLst>
-            <a:outerShdw blurRad="101600" dist="25400" dir="5400000" algn="bl" rotWithShape="0">
-              <a:srgbClr val="1B2540">
-                <a:alpha val="14000"/>
-              </a:srgbClr>
-            </a:outerShdw>
-          </a:effectLst>
-        </p:spPr>
-      </p:sp>
-      <p:sp>
-        <p:nvSpPr>
-          <p:cNvPr id="29" name="Tile letter Safety"/>
-          <p:cNvSpPr txBox="1"/>
-          <p:nvPr/>
-        </p:nvSpPr>
-        <p:spPr>
-          <a:xfrm>
-            <a:off x="5440680" y="3511296"/>
-            <a:ext cx="1371600" cy="457200"/>
-          </a:xfrm>
-          <a:prstGeom prst="rect">
-            <a:avLst/>
-          </a:prstGeom>
-          <a:noFill/>
-          <a:ln/>
-        </p:spPr>
-        <p:txBody>
-          <a:bodyPr wrap="square" lIns="0" tIns="0" rIns="0" bIns="0" rtlCol="0" anchor="ctr"/>
-          <a:lstStyle/>
-          <a:p>
-            <a:pPr marL="0" indent="0">
-              <a:buNone/>
-            </a:pPr>
-            <a:r>
-              <a:rPr lang="en-US" sz="2600" b="1" dirty="0">
-                <a:solidFill>
-                  <a:schemeClr val="accent4"/>
-                </a:solidFill>
-                <a:latin typeface="+mj-lt" pitchFamily="34" charset="0"/>
-                <a:ea typeface="+mj-lt" pitchFamily="34" charset="-122"/>
-                <a:cs typeface="+mj-lt" pitchFamily="34" charset="-120"/>
-              </a:rPr>
-              <a:t>S</a:t>
-            </a:r>
-            <a:endParaRPr lang="en-US" sz="2600" dirty="0"/>
-          </a:p>
-        </p:txBody>
-      </p:sp>
-      <p:sp>
-        <p:nvSpPr>
-          <p:cNvPr id="30" name="Tile word Safety"/>
-          <p:cNvSpPr txBox="1"/>
-          <p:nvPr/>
-        </p:nvSpPr>
-        <p:spPr>
-          <a:xfrm>
-            <a:off x="5440680" y="3968496"/>
-            <a:ext cx="1417320" cy="502920"/>
-          </a:xfrm>
-          <a:prstGeom prst="rect">
-            <a:avLst/>
-          </a:prstGeom>
-          <a:noFill/>
-          <a:ln/>
-        </p:spPr>
-        <p:txBody>
-          <a:bodyPr wrap="square" lIns="0" tIns="0" rIns="0" bIns="0" rtlCol="0" anchor="t"/>
-          <a:lstStyle/>
-          <a:p>
-            <a:pPr marL="0" indent="0">
-              <a:buNone/>
-            </a:pPr>
-            <a:r>
-              <a:rPr lang="en-US" sz="1400" dirty="0">
-                <a:solidFill>
-                  <a:schemeClr val="tx2"/>
-                </a:solidFill>
-              </a:rPr>
-              <a:t>Safety</a:t>
-            </a:r>
-            <a:endParaRPr lang="en-US" sz="1400" dirty="0"/>
-          </a:p>
-        </p:txBody>
-      </p:sp>
-      <p:sp>
-        <p:nvSpPr>
-          <p:cNvPr id="31" name="Tile Strength, spirituality"/>
-          <p:cNvSpPr/>
-          <p:nvPr/>
-        </p:nvSpPr>
-        <p:spPr>
-          <a:xfrm>
-            <a:off x="7050024" y="3465576"/>
-            <a:ext cx="1600200" cy="1051560"/>
-          </a:xfrm>
-          <a:prstGeom prst="roundRect">
-            <a:avLst>
-              <a:gd name="adj" fmla="val 8696"/>
-            </a:avLst>
-          </a:prstGeom>
-          <a:solidFill>
-            <a:schemeClr val="accent3"/>
-          </a:solidFill>
-          <a:ln w="12700">
-            <a:solidFill>
-              <a:schemeClr val="accent3"/>
-            </a:solidFill>
-            <a:prstDash val="solid"/>
-          </a:ln>
-          <a:effectLst>
-            <a:outerShdw blurRad="101600" dist="25400" dir="5400000" algn="bl" rotWithShape="0">
-              <a:srgbClr val="1B2540">
-                <a:alpha val="14000"/>
-              </a:srgbClr>
-            </a:outerShdw>
-          </a:effectLst>
-        </p:spPr>
-      </p:sp>
-      <p:sp>
-        <p:nvSpPr>
-          <p:cNvPr id="32" name="Tile letter Strength, spirituality"/>
-          <p:cNvSpPr txBox="1"/>
-          <p:nvPr/>
-        </p:nvSpPr>
-        <p:spPr>
-          <a:xfrm>
-            <a:off x="7159752" y="3511296"/>
-            <a:ext cx="1371600" cy="457200"/>
-          </a:xfrm>
-          <a:prstGeom prst="rect">
-            <a:avLst/>
-          </a:prstGeom>
-          <a:noFill/>
-          <a:ln/>
-        </p:spPr>
-        <p:txBody>
-          <a:bodyPr wrap="square" lIns="0" tIns="0" rIns="0" bIns="0" rtlCol="0" anchor="ctr"/>
-          <a:lstStyle/>
-          <a:p>
-            <a:pPr marL="0" indent="0">
-              <a:buNone/>
-            </a:pPr>
-            <a:r>
-              <a:rPr lang="en-US" sz="2600" b="1" dirty="0">
-                <a:solidFill>
-                  <a:schemeClr val="tx1"/>
-                </a:solidFill>
-                <a:latin typeface="+mj-lt" pitchFamily="34" charset="0"/>
-                <a:ea typeface="+mj-lt" pitchFamily="34" charset="-122"/>
-                <a:cs typeface="+mj-lt" pitchFamily="34" charset="-120"/>
-              </a:rPr>
-              <a:t>S</a:t>
-            </a:r>
-            <a:endParaRPr lang="en-US" sz="2600" dirty="0"/>
-          </a:p>
-        </p:txBody>
-      </p:sp>
-      <p:sp>
-        <p:nvSpPr>
-          <p:cNvPr id="33" name="Tile word Strength, spirituality"/>
-          <p:cNvSpPr txBox="1"/>
-          <p:nvPr/>
-        </p:nvSpPr>
-        <p:spPr>
-          <a:xfrm>
-            <a:off x="7159752" y="3968496"/>
-            <a:ext cx="1417320" cy="502920"/>
-          </a:xfrm>
-          <a:prstGeom prst="rect">
-            <a:avLst/>
-          </a:prstGeom>
-          <a:noFill/>
-          <a:ln/>
-        </p:spPr>
-        <p:txBody>
-          <a:bodyPr wrap="square" lIns="0" tIns="0" rIns="0" bIns="0" rtlCol="0" anchor="t"/>
-          <a:lstStyle/>
-          <a:p>
-            <a:pPr marL="0" indent="0">
-              <a:buNone/>
-            </a:pPr>
-            <a:r>
-              <a:rPr lang="en-US" sz="1400" dirty="0">
-                <a:solidFill>
-                  <a:schemeClr val="tx1"/>
-                </a:solidFill>
-              </a:rPr>
-              <a:t>Strength, spirituality</a:t>
-            </a:r>
-            <a:endParaRPr lang="en-US" sz="1400" dirty="0"/>
-          </a:p>
-        </p:txBody>
-      </p:sp>
-      <p:sp>
-        <p:nvSpPr>
-          <p:cNvPr id="34" name="Back button">
-            <a:hlinkClick r:id="rId5" action="ppaction://hlinksldjump" tooltip="Previous slide"/>
+      <p:sp>
+        <p:nvSpPr>
+          <p:cNvPr id="7" name="Menu button">
+            <a:hlinkClick r:id="rId5" action="ppaction://hlinksldjump" tooltip="Back to the topic menu"/>
           </p:cNvPr>
           <p:cNvSpPr/>
           <p:nvPr/>
         </p:nvSpPr>
         <p:spPr>
           <a:xfrm>
-            <a:off x="6446520" y="4636008"/>
-            <a:ext cx="1051560" cy="347472"/>
+            <a:off x="2377440" y="3977640"/>
+            <a:ext cx="1280160" cy="420624"/>
           </a:xfrm>
           <a:prstGeom prst="roundRect">
             <a:avLst>
@@ -15388,7 +14277,7 @@
             </a:avLst>
           </a:prstGeom>
           <a:solidFill>
-            <a:schemeClr val="bg1"/>
+            <a:schemeClr val="tx2"/>
           </a:solidFill>
           <a:ln/>
         </p:spPr>
@@ -15402,52 +14291,10 @@
             <a:r>
               <a:rPr lang="en-US" sz="1400" b="1" dirty="0">
                 <a:solidFill>
-                  <a:schemeClr val="tx1"/>
-                </a:solidFill>
-              </a:rPr>
-              <a:t>‹ Back</a:t>
-            </a:r>
-            <a:endParaRPr lang="en-US" sz="1400" dirty="0"/>
-          </a:p>
-        </p:txBody>
-      </p:sp>
-      <p:sp>
-        <p:nvSpPr>
-          <p:cNvPr id="35" name="Next button">
-            <a:hlinkClick r:id="rId6" action="ppaction://hlinksldjump" tooltip="Next slide"/>
-          </p:cNvPr>
-          <p:cNvSpPr/>
-          <p:nvPr/>
-        </p:nvSpPr>
-        <p:spPr>
-          <a:xfrm>
-            <a:off x="7589520" y="4636008"/>
-            <a:ext cx="1097280" cy="347472"/>
-          </a:xfrm>
-          <a:prstGeom prst="roundRect">
-            <a:avLst>
-              <a:gd name="adj" fmla="val 50000"/>
-            </a:avLst>
-          </a:prstGeom>
-          <a:solidFill>
-            <a:schemeClr val="tx1"/>
-          </a:solidFill>
-          <a:ln/>
-        </p:spPr>
-        <p:txBody>
-          <a:bodyPr wrap="square" lIns="0" tIns="0" rIns="0" bIns="0" rtlCol="0" anchor="ctr"/>
-          <a:lstStyle/>
-          <a:p>
-            <a:pPr marL="0" indent="0" algn="ctr">
-              <a:buNone/>
-            </a:pPr>
-            <a:r>
-              <a:rPr lang="en-US" sz="1400" b="1" dirty="0">
-                <a:solidFill>
                   <a:schemeClr val="bg1"/>
                 </a:solidFill>
               </a:rPr>
-              <a:t>Quiz ›</a:t>
+              <a:t>Menu</a:t>
             </a:r>
             <a:endParaRPr lang="en-US" sz="1400" dirty="0"/>
           </a:p>

</xml_diff>